<commit_message>
Pushing a bunch of updates/upgrades to the PPTs.
</commit_message>
<xml_diff>
--- a/Slides/Chapter04.pptx
+++ b/Slides/Chapter04.pptx
@@ -2,7 +2,7 @@
 <file path=ppt/presentation.xml><?xml version="1.0" encoding="utf-8"?>
 <p:presentation xmlns:a="http://schemas.openxmlformats.org/drawingml/2006/main" xmlns:r="http://schemas.openxmlformats.org/officeDocument/2006/relationships" xmlns:p="http://schemas.openxmlformats.org/presentationml/2006/main" saveSubsetFonts="1" autoCompressPictures="0">
   <p:sldMasterIdLst>
-    <p:sldMasterId id="2147483660" r:id="rId1"/>
+    <p:sldMasterId id="2147483669" r:id="rId1"/>
   </p:sldMasterIdLst>
   <p:notesMasterIdLst>
     <p:notesMasterId r:id="rId28"/>
@@ -222,7 +222,7 @@
           <a:p>
             <a:fld id="{E67FAF9A-0955-624D-88B2-AC31179CA836}" type="datetimeFigureOut">
               <a:rPr lang="en-US" smtClean="0"/>
-              <a:t>9/22/26</a:t>
+              <a:t>10/8/26</a:t>
             </a:fld>
             <a:endParaRPr lang="en-US"/>
           </a:p>
@@ -1022,7 +1022,7 @@
         </p:nvSpPr>
         <p:spPr>
           <a:xfrm>
-            <a:off x="914400" y="1058938"/>
+            <a:off x="914400" y="1058940"/>
             <a:ext cx="10363200" cy="1470025"/>
           </a:xfrm>
           <a:solidFill>
@@ -1074,9 +1074,14 @@
         </p:nvSpPr>
         <p:spPr>
           <a:xfrm>
-            <a:off x="2281186" y="2983610"/>
+            <a:off x="2281187" y="2983612"/>
             <a:ext cx="7609479" cy="1009561"/>
           </a:xfrm>
+          <a:prstGeom prst="roundRect">
+            <a:avLst>
+              <a:gd name="adj" fmla="val 37895"/>
+            </a:avLst>
+          </a:prstGeom>
           <a:solidFill>
             <a:schemeClr val="bg1">
               <a:alpha val="95000"/>
@@ -1135,10 +1140,98 @@
           </a:p>
         </p:txBody>
       </p:sp>
+      <p:sp>
+        <p:nvSpPr>
+          <p:cNvPr id="2" name="Date Placeholder 1">
+            <a:extLst>
+              <a:ext uri="{FF2B5EF4-FFF2-40B4-BE49-F238E27FC236}">
+                <a16:creationId xmlns:a16="http://schemas.microsoft.com/office/drawing/2014/main" id="{9B409C91-6E3E-5409-2F44-4E770C50190C}"/>
+              </a:ext>
+            </a:extLst>
+          </p:cNvPr>
+          <p:cNvSpPr>
+            <a:spLocks noGrp="1"/>
+          </p:cNvSpPr>
+          <p:nvPr>
+            <p:ph type="dt" sz="half" idx="11"/>
+          </p:nvPr>
+        </p:nvSpPr>
+        <p:spPr/>
+        <p:txBody>
+          <a:bodyPr/>
+          <a:lstStyle/>
+          <a:p>
+            <a:fld id="{35571CA6-6DF2-9148-B84D-05AEB88A6F3B}" type="datetime1">
+              <a:rPr lang="en-US" smtClean="0"/>
+              <a:t>10/8/26</a:t>
+            </a:fld>
+            <a:endParaRPr lang="en-US" dirty="0"/>
+          </a:p>
+        </p:txBody>
+      </p:sp>
+      <p:sp>
+        <p:nvSpPr>
+          <p:cNvPr id="4" name="Footer Placeholder 3">
+            <a:extLst>
+              <a:ext uri="{FF2B5EF4-FFF2-40B4-BE49-F238E27FC236}">
+                <a16:creationId xmlns:a16="http://schemas.microsoft.com/office/drawing/2014/main" id="{594118C6-B924-AA1F-AEFC-17607998D78C}"/>
+              </a:ext>
+            </a:extLst>
+          </p:cNvPr>
+          <p:cNvSpPr>
+            <a:spLocks noGrp="1"/>
+          </p:cNvSpPr>
+          <p:nvPr>
+            <p:ph type="ftr" sz="quarter" idx="12"/>
+          </p:nvPr>
+        </p:nvSpPr>
+        <p:spPr/>
+        <p:txBody>
+          <a:bodyPr/>
+          <a:lstStyle/>
+          <a:p>
+            <a:r>
+              <a:rPr lang="en-US"/>
+              <a:t>© Steve Beaty and others as cited</a:t>
+            </a:r>
+            <a:endParaRPr lang="en-US" dirty="0"/>
+          </a:p>
+        </p:txBody>
+      </p:sp>
+      <p:sp>
+        <p:nvSpPr>
+          <p:cNvPr id="5" name="Slide Number Placeholder 4">
+            <a:extLst>
+              <a:ext uri="{FF2B5EF4-FFF2-40B4-BE49-F238E27FC236}">
+                <a16:creationId xmlns:a16="http://schemas.microsoft.com/office/drawing/2014/main" id="{29E93608-8881-8010-4D06-440F9FBB6BE8}"/>
+              </a:ext>
+            </a:extLst>
+          </p:cNvPr>
+          <p:cNvSpPr>
+            <a:spLocks noGrp="1"/>
+          </p:cNvSpPr>
+          <p:nvPr>
+            <p:ph type="sldNum" sz="quarter" idx="13"/>
+          </p:nvPr>
+        </p:nvSpPr>
+        <p:spPr/>
+        <p:txBody>
+          <a:bodyPr/>
+          <a:lstStyle/>
+          <a:p>
+            <a:fld id="{37D050C8-32A2-8944-BC0A-E76DEAECED1E}" type="slidenum">
+              <a:rPr lang="en-US" smtClean="0"/>
+              <a:pPr/>
+              <a:t>‹#›</a:t>
+            </a:fld>
+            <a:endParaRPr lang="en-US" dirty="0"/>
+          </a:p>
+        </p:txBody>
+      </p:sp>
     </p:spTree>
     <p:extLst>
       <p:ext uri="{BB962C8B-B14F-4D97-AF65-F5344CB8AC3E}">
-        <p14:creationId xmlns:p14="http://schemas.microsoft.com/office/powerpoint/2010/main" val="3645106438"/>
+        <p14:creationId xmlns:p14="http://schemas.microsoft.com/office/powerpoint/2010/main" val="1471950434"/>
       </p:ext>
     </p:extLst>
   </p:cSld>
@@ -1147,12 +1240,12 @@
   </p:clrMapOvr>
   <mc:AlternateContent xmlns:mc="http://schemas.openxmlformats.org/markup-compatibility/2006" xmlns:p14="http://schemas.microsoft.com/office/powerpoint/2010/main">
     <mc:Choice Requires="p14">
-      <p:transition spd="slow" p14:dur="1200">
-        <p14:prism/>
+      <p:transition spd="slow" p14:dur="2000">
+        <p14:prism isContent="1"/>
       </p:transition>
     </mc:Choice>
     <mc:Fallback xmlns="">
-      <p:transition xmlns:p14="http://schemas.microsoft.com/office/powerpoint/2010/main" spd="slow">
+      <p:transition spd="slow">
         <p:fade/>
       </p:transition>
     </mc:Fallback>
@@ -1257,7 +1350,13 @@
       </p:sp>
       <p:sp>
         <p:nvSpPr>
-          <p:cNvPr id="4" name="Date Placeholder 3"/>
+          <p:cNvPr id="8" name="Date Placeholder 7">
+            <a:extLst>
+              <a:ext uri="{FF2B5EF4-FFF2-40B4-BE49-F238E27FC236}">
+                <a16:creationId xmlns:a16="http://schemas.microsoft.com/office/drawing/2014/main" id="{DB39033B-5031-2DE5-AF8A-E269BDEE889F}"/>
+              </a:ext>
+            </a:extLst>
+          </p:cNvPr>
           <p:cNvSpPr>
             <a:spLocks noGrp="1"/>
           </p:cNvSpPr>
@@ -1265,22 +1364,14 @@
             <p:ph type="dt" sz="half" idx="10"/>
           </p:nvPr>
         </p:nvSpPr>
-        <p:spPr>
-          <a:xfrm>
-            <a:off x="4406051" y="6308727"/>
-            <a:ext cx="1169155" cy="485424"/>
-          </a:xfrm>
-          <a:prstGeom prst="rect">
-            <a:avLst/>
-          </a:prstGeom>
-        </p:spPr>
+        <p:spPr/>
         <p:txBody>
           <a:bodyPr/>
           <a:lstStyle/>
           <a:p>
-            <a:fld id="{19E4FA1D-83B2-3A4E-B175-FAA1598AB2F4}" type="datetimeFigureOut">
+            <a:fld id="{6C95D654-8466-B040-96CE-9F5E394C34ED}" type="datetime1">
               <a:rPr lang="en-US" smtClean="0"/>
-              <a:t>9/22/26</a:t>
+              <a:t>10/8/26</a:t>
             </a:fld>
             <a:endParaRPr lang="en-US"/>
           </a:p>
@@ -1288,7 +1379,13 @@
       </p:sp>
       <p:sp>
         <p:nvSpPr>
-          <p:cNvPr id="5" name="Footer Placeholder 4"/>
+          <p:cNvPr id="9" name="Footer Placeholder 8">
+            <a:extLst>
+              <a:ext uri="{FF2B5EF4-FFF2-40B4-BE49-F238E27FC236}">
+                <a16:creationId xmlns:a16="http://schemas.microsoft.com/office/drawing/2014/main" id="{8CC0AD20-1FAB-5697-725E-A23B4E11A490}"/>
+              </a:ext>
+            </a:extLst>
+          </p:cNvPr>
           <p:cNvSpPr>
             <a:spLocks noGrp="1"/>
           </p:cNvSpPr>
@@ -1301,13 +1398,22 @@
           <a:bodyPr/>
           <a:lstStyle/>
           <a:p>
-            <a:endParaRPr lang="en-US"/>
-          </a:p>
-        </p:txBody>
-      </p:sp>
-      <p:sp>
-        <p:nvSpPr>
-          <p:cNvPr id="6" name="Slide Number Placeholder 5"/>
+            <a:r>
+              <a:rPr lang="en-US"/>
+              <a:t>© Steve Beaty and others as cited</a:t>
+            </a:r>
+          </a:p>
+        </p:txBody>
+      </p:sp>
+      <p:sp>
+        <p:nvSpPr>
+          <p:cNvPr id="10" name="SlideNumberWithTotal">
+            <a:extLst>
+              <a:ext uri="{FF2B5EF4-FFF2-40B4-BE49-F238E27FC236}">
+                <a16:creationId xmlns:a16="http://schemas.microsoft.com/office/drawing/2014/main" id="{C85ADDAF-31A4-85DD-32A3-DD43B60F68C2}"/>
+              </a:ext>
+            </a:extLst>
+          </p:cNvPr>
           <p:cNvSpPr>
             <a:spLocks noGrp="1"/>
           </p:cNvSpPr>
@@ -1331,7 +1437,7 @@
     </p:spTree>
     <p:extLst>
       <p:ext uri="{BB962C8B-B14F-4D97-AF65-F5344CB8AC3E}">
-        <p14:creationId xmlns:p14="http://schemas.microsoft.com/office/powerpoint/2010/main" val="94989645"/>
+        <p14:creationId xmlns:p14="http://schemas.microsoft.com/office/powerpoint/2010/main" val="4013949438"/>
       </p:ext>
     </p:extLst>
   </p:cSld>
@@ -1340,12 +1446,12 @@
   </p:clrMapOvr>
   <mc:AlternateContent xmlns:mc="http://schemas.openxmlformats.org/markup-compatibility/2006" xmlns:p14="http://schemas.microsoft.com/office/powerpoint/2010/main">
     <mc:Choice Requires="p14">
-      <p:transition spd="slow" p14:dur="1200">
-        <p14:prism/>
+      <p:transition spd="slow" p14:dur="2000">
+        <p14:prism isContent="1"/>
       </p:transition>
     </mc:Choice>
     <mc:Fallback xmlns="">
-      <p:transition xmlns:p14="http://schemas.microsoft.com/office/powerpoint/2010/main" spd="slow">
+      <p:transition spd="slow">
         <p:fade/>
       </p:transition>
     </mc:Fallback>
@@ -1438,7 +1544,13 @@
       </p:sp>
       <p:sp>
         <p:nvSpPr>
-          <p:cNvPr id="4" name="Date Placeholder 3"/>
+          <p:cNvPr id="8" name="Date Placeholder 7">
+            <a:extLst>
+              <a:ext uri="{FF2B5EF4-FFF2-40B4-BE49-F238E27FC236}">
+                <a16:creationId xmlns:a16="http://schemas.microsoft.com/office/drawing/2014/main" id="{DEEF9C46-CD18-5177-41DC-5A44F050BB88}"/>
+              </a:ext>
+            </a:extLst>
+          </p:cNvPr>
           <p:cNvSpPr>
             <a:spLocks noGrp="1"/>
           </p:cNvSpPr>
@@ -1446,22 +1558,14 @@
             <p:ph type="dt" sz="half" idx="10"/>
           </p:nvPr>
         </p:nvSpPr>
-        <p:spPr>
-          <a:xfrm>
-            <a:off x="4406051" y="6308727"/>
-            <a:ext cx="1169155" cy="485424"/>
-          </a:xfrm>
-          <a:prstGeom prst="rect">
-            <a:avLst/>
-          </a:prstGeom>
-        </p:spPr>
+        <p:spPr/>
         <p:txBody>
           <a:bodyPr/>
           <a:lstStyle/>
           <a:p>
-            <a:fld id="{19E4FA1D-83B2-3A4E-B175-FAA1598AB2F4}" type="datetimeFigureOut">
+            <a:fld id="{58C6E784-80CE-E540-B473-76F7ED05F7B9}" type="datetime1">
               <a:rPr lang="en-US" smtClean="0"/>
-              <a:t>9/22/26</a:t>
+              <a:t>10/8/26</a:t>
             </a:fld>
             <a:endParaRPr lang="en-US"/>
           </a:p>
@@ -1469,7 +1573,13 @@
       </p:sp>
       <p:sp>
         <p:nvSpPr>
-          <p:cNvPr id="5" name="Footer Placeholder 4"/>
+          <p:cNvPr id="9" name="Footer Placeholder 8">
+            <a:extLst>
+              <a:ext uri="{FF2B5EF4-FFF2-40B4-BE49-F238E27FC236}">
+                <a16:creationId xmlns:a16="http://schemas.microsoft.com/office/drawing/2014/main" id="{A6447FE1-5C78-6FAD-D883-46A9B247C887}"/>
+              </a:ext>
+            </a:extLst>
+          </p:cNvPr>
           <p:cNvSpPr>
             <a:spLocks noGrp="1"/>
           </p:cNvSpPr>
@@ -1482,13 +1592,22 @@
           <a:bodyPr/>
           <a:lstStyle/>
           <a:p>
-            <a:endParaRPr lang="en-US"/>
-          </a:p>
-        </p:txBody>
-      </p:sp>
-      <p:sp>
-        <p:nvSpPr>
-          <p:cNvPr id="6" name="Slide Number Placeholder 5"/>
+            <a:r>
+              <a:rPr lang="en-US"/>
+              <a:t>© Steve Beaty and others as cited</a:t>
+            </a:r>
+          </a:p>
+        </p:txBody>
+      </p:sp>
+      <p:sp>
+        <p:nvSpPr>
+          <p:cNvPr id="10" name="Slide Number Placeholder 9">
+            <a:extLst>
+              <a:ext uri="{FF2B5EF4-FFF2-40B4-BE49-F238E27FC236}">
+                <a16:creationId xmlns:a16="http://schemas.microsoft.com/office/drawing/2014/main" id="{3BEAED22-447D-B036-C934-3337B57F57F0}"/>
+              </a:ext>
+            </a:extLst>
+          </p:cNvPr>
           <p:cNvSpPr>
             <a:spLocks noGrp="1"/>
           </p:cNvSpPr>
@@ -1512,13 +1631,25 @@
     </p:spTree>
     <p:extLst>
       <p:ext uri="{BB962C8B-B14F-4D97-AF65-F5344CB8AC3E}">
-        <p14:creationId xmlns:p14="http://schemas.microsoft.com/office/powerpoint/2010/main" val="1408746863"/>
+        <p14:creationId xmlns:p14="http://schemas.microsoft.com/office/powerpoint/2010/main" val="114596404"/>
       </p:ext>
     </p:extLst>
   </p:cSld>
   <p:clrMapOvr>
     <a:masterClrMapping/>
   </p:clrMapOvr>
+  <mc:AlternateContent xmlns:mc="http://schemas.openxmlformats.org/markup-compatibility/2006" xmlns:p14="http://schemas.microsoft.com/office/powerpoint/2010/main">
+    <mc:Choice Requires="p14">
+      <p:transition spd="slow" p14:dur="2000">
+        <p14:prism isContent="1"/>
+      </p:transition>
+    </mc:Choice>
+    <mc:Fallback xmlns="">
+      <p:transition spd="slow">
+        <p:fade/>
+      </p:transition>
+    </mc:Fallback>
+  </mc:AlternateContent>
 </p:sldLayout>
 </file>
 
@@ -1573,7 +1704,7 @@
         </p:nvSpPr>
         <p:spPr>
           <a:xfrm>
-            <a:off x="609600" y="1602487"/>
+            <a:off x="609600" y="1602488"/>
             <a:ext cx="5321600" cy="4525963"/>
           </a:xfrm>
           <a:ln w="25400" cap="flat">
@@ -1603,79 +1734,6 @@
               <a:rPr lang="en-US"/>
               <a:t>Click to edit Master text styles</a:t>
             </a:r>
-          </a:p>
-        </p:txBody>
-      </p:sp>
-      <p:sp>
-        <p:nvSpPr>
-          <p:cNvPr id="4" name="Date Placeholder 3"/>
-          <p:cNvSpPr>
-            <a:spLocks noGrp="1"/>
-          </p:cNvSpPr>
-          <p:nvPr>
-            <p:ph type="dt" sz="half" idx="10"/>
-          </p:nvPr>
-        </p:nvSpPr>
-        <p:spPr>
-          <a:xfrm>
-            <a:off x="4406051" y="6308727"/>
-            <a:ext cx="1169155" cy="485424"/>
-          </a:xfrm>
-          <a:prstGeom prst="rect">
-            <a:avLst/>
-          </a:prstGeom>
-        </p:spPr>
-        <p:txBody>
-          <a:bodyPr/>
-          <a:lstStyle/>
-          <a:p>
-            <a:fld id="{19E4FA1D-83B2-3A4E-B175-FAA1598AB2F4}" type="datetimeFigureOut">
-              <a:rPr lang="en-US" smtClean="0"/>
-              <a:t>9/22/26</a:t>
-            </a:fld>
-            <a:endParaRPr lang="en-US"/>
-          </a:p>
-        </p:txBody>
-      </p:sp>
-      <p:sp>
-        <p:nvSpPr>
-          <p:cNvPr id="5" name="Footer Placeholder 4"/>
-          <p:cNvSpPr>
-            <a:spLocks noGrp="1"/>
-          </p:cNvSpPr>
-          <p:nvPr>
-            <p:ph type="ftr" sz="quarter" idx="11"/>
-          </p:nvPr>
-        </p:nvSpPr>
-        <p:spPr/>
-        <p:txBody>
-          <a:bodyPr/>
-          <a:lstStyle/>
-          <a:p>
-            <a:endParaRPr lang="en-US"/>
-          </a:p>
-        </p:txBody>
-      </p:sp>
-      <p:sp>
-        <p:nvSpPr>
-          <p:cNvPr id="6" name="Slide Number Placeholder 5"/>
-          <p:cNvSpPr>
-            <a:spLocks noGrp="1"/>
-          </p:cNvSpPr>
-          <p:nvPr>
-            <p:ph type="sldNum" sz="quarter" idx="12"/>
-          </p:nvPr>
-        </p:nvSpPr>
-        <p:spPr/>
-        <p:txBody>
-          <a:bodyPr/>
-          <a:lstStyle/>
-          <a:p>
-            <a:fld id="{DF323A44-C1E5-0B49-AAF6-7E9549B7BFD2}" type="slidenum">
-              <a:rPr lang="en-US" smtClean="0"/>
-              <a:t>‹#›</a:t>
-            </a:fld>
-            <a:endParaRPr lang="en-US"/>
           </a:p>
         </p:txBody>
       </p:sp>
@@ -1729,16 +1787,114 @@
           </a:p>
         </p:txBody>
       </p:sp>
+      <p:sp>
+        <p:nvSpPr>
+          <p:cNvPr id="9" name="Date Placeholder 8">
+            <a:extLst>
+              <a:ext uri="{FF2B5EF4-FFF2-40B4-BE49-F238E27FC236}">
+                <a16:creationId xmlns:a16="http://schemas.microsoft.com/office/drawing/2014/main" id="{71D19512-769A-1A2D-AE4B-615827F538DF}"/>
+              </a:ext>
+            </a:extLst>
+          </p:cNvPr>
+          <p:cNvSpPr>
+            <a:spLocks noGrp="1"/>
+          </p:cNvSpPr>
+          <p:nvPr>
+            <p:ph type="dt" sz="half" idx="14"/>
+          </p:nvPr>
+        </p:nvSpPr>
+        <p:spPr/>
+        <p:txBody>
+          <a:bodyPr/>
+          <a:lstStyle/>
+          <a:p>
+            <a:fld id="{98D49D47-5C67-C942-801E-D02AB59464BA}" type="datetime1">
+              <a:rPr lang="en-US" smtClean="0"/>
+              <a:t>10/8/26</a:t>
+            </a:fld>
+            <a:endParaRPr lang="en-US"/>
+          </a:p>
+        </p:txBody>
+      </p:sp>
+      <p:sp>
+        <p:nvSpPr>
+          <p:cNvPr id="10" name="Footer Placeholder 9">
+            <a:extLst>
+              <a:ext uri="{FF2B5EF4-FFF2-40B4-BE49-F238E27FC236}">
+                <a16:creationId xmlns:a16="http://schemas.microsoft.com/office/drawing/2014/main" id="{88537417-0F7B-4AB8-2913-FC8911CF4DFA}"/>
+              </a:ext>
+            </a:extLst>
+          </p:cNvPr>
+          <p:cNvSpPr>
+            <a:spLocks noGrp="1"/>
+          </p:cNvSpPr>
+          <p:nvPr>
+            <p:ph type="ftr" sz="quarter" idx="15"/>
+          </p:nvPr>
+        </p:nvSpPr>
+        <p:spPr/>
+        <p:txBody>
+          <a:bodyPr/>
+          <a:lstStyle/>
+          <a:p>
+            <a:r>
+              <a:rPr lang="en-US"/>
+              <a:t>© Steve Beaty and others as cited</a:t>
+            </a:r>
+          </a:p>
+        </p:txBody>
+      </p:sp>
+      <p:sp>
+        <p:nvSpPr>
+          <p:cNvPr id="11" name="Slide Number Placeholder 10">
+            <a:extLst>
+              <a:ext uri="{FF2B5EF4-FFF2-40B4-BE49-F238E27FC236}">
+                <a16:creationId xmlns:a16="http://schemas.microsoft.com/office/drawing/2014/main" id="{6C508543-3E8A-F349-1E14-7A34163E0A10}"/>
+              </a:ext>
+            </a:extLst>
+          </p:cNvPr>
+          <p:cNvSpPr>
+            <a:spLocks noGrp="1"/>
+          </p:cNvSpPr>
+          <p:nvPr>
+            <p:ph type="sldNum" sz="quarter" idx="16"/>
+          </p:nvPr>
+        </p:nvSpPr>
+        <p:spPr/>
+        <p:txBody>
+          <a:bodyPr/>
+          <a:lstStyle/>
+          <a:p>
+            <a:fld id="{DF323A44-C1E5-0B49-AAF6-7E9549B7BFD2}" type="slidenum">
+              <a:rPr lang="en-US" smtClean="0"/>
+              <a:t>‹#›</a:t>
+            </a:fld>
+            <a:endParaRPr lang="en-US"/>
+          </a:p>
+        </p:txBody>
+      </p:sp>
     </p:spTree>
     <p:extLst>
       <p:ext uri="{BB962C8B-B14F-4D97-AF65-F5344CB8AC3E}">
-        <p14:creationId xmlns:p14="http://schemas.microsoft.com/office/powerpoint/2010/main" val="2747454476"/>
+        <p14:creationId xmlns:p14="http://schemas.microsoft.com/office/powerpoint/2010/main" val="3914130999"/>
       </p:ext>
     </p:extLst>
   </p:cSld>
   <p:clrMapOvr>
     <a:masterClrMapping/>
   </p:clrMapOvr>
+  <mc:AlternateContent xmlns:mc="http://schemas.openxmlformats.org/markup-compatibility/2006" xmlns:p14="http://schemas.microsoft.com/office/powerpoint/2010/main">
+    <mc:Choice Requires="p14">
+      <p:transition spd="slow" p14:dur="2000">
+        <p14:prism isContent="1"/>
+      </p:transition>
+    </mc:Choice>
+    <mc:Fallback xmlns="">
+      <p:transition spd="slow">
+        <p:fade/>
+      </p:transition>
+    </mc:Fallback>
+  </mc:AlternateContent>
 </p:sldLayout>
 </file>
 
@@ -1961,7 +2117,7 @@
         </p:nvSpPr>
         <p:spPr>
           <a:xfrm>
-            <a:off x="4406051" y="6308727"/>
+            <a:off x="4406052" y="6308727"/>
             <a:ext cx="1169155" cy="485424"/>
           </a:xfrm>
           <a:prstGeom prst="rect">
@@ -1972,9 +2128,9 @@
           <a:bodyPr/>
           <a:lstStyle/>
           <a:p>
-            <a:fld id="{19E4FA1D-83B2-3A4E-B175-FAA1598AB2F4}" type="datetimeFigureOut">
+            <a:fld id="{0C0A3EDA-0FB5-C64B-8C97-EEA909CAC639}" type="datetime1">
               <a:rPr lang="en-US" smtClean="0"/>
-              <a:t>9/22/26</a:t>
+              <a:t>10/8/26</a:t>
             </a:fld>
             <a:endParaRPr lang="en-US"/>
           </a:p>
@@ -1995,7 +2151,10 @@
           <a:bodyPr/>
           <a:lstStyle/>
           <a:p>
-            <a:endParaRPr lang="en-US"/>
+            <a:r>
+              <a:rPr lang="en-US"/>
+              <a:t>© Steve Beaty and others as cited</a:t>
+            </a:r>
           </a:p>
         </p:txBody>
       </p:sp>
@@ -2025,7 +2184,7 @@
     </p:spTree>
     <p:extLst>
       <p:ext uri="{BB962C8B-B14F-4D97-AF65-F5344CB8AC3E}">
-        <p14:creationId xmlns:p14="http://schemas.microsoft.com/office/powerpoint/2010/main" val="3217283207"/>
+        <p14:creationId xmlns:p14="http://schemas.microsoft.com/office/powerpoint/2010/main" val="875617986"/>
       </p:ext>
     </p:extLst>
   </p:cSld>
@@ -2034,12 +2193,12 @@
   </p:clrMapOvr>
   <mc:AlternateContent xmlns:mc="http://schemas.openxmlformats.org/markup-compatibility/2006" xmlns:p14="http://schemas.microsoft.com/office/powerpoint/2010/main">
     <mc:Choice Requires="p14">
-      <p:transition spd="slow" p14:dur="1200">
-        <p14:prism/>
+      <p:transition spd="slow" p14:dur="2000">
+        <p14:prism isContent="1"/>
       </p:transition>
     </mc:Choice>
     <mc:Fallback xmlns="">
-      <p:transition xmlns:p14="http://schemas.microsoft.com/office/powerpoint/2010/main" spd="slow">
+      <p:transition spd="slow">
         <p:fade/>
       </p:transition>
     </mc:Fallback>
@@ -2088,7 +2247,13 @@
       </p:sp>
       <p:sp>
         <p:nvSpPr>
-          <p:cNvPr id="3" name="Date Placeholder 2"/>
+          <p:cNvPr id="7" name="Date Placeholder 6">
+            <a:extLst>
+              <a:ext uri="{FF2B5EF4-FFF2-40B4-BE49-F238E27FC236}">
+                <a16:creationId xmlns:a16="http://schemas.microsoft.com/office/drawing/2014/main" id="{CD92DC31-8A1B-D6EF-9DCB-F31748611FEA}"/>
+              </a:ext>
+            </a:extLst>
+          </p:cNvPr>
           <p:cNvSpPr>
             <a:spLocks noGrp="1"/>
           </p:cNvSpPr>
@@ -2096,22 +2261,14 @@
             <p:ph type="dt" sz="half" idx="10"/>
           </p:nvPr>
         </p:nvSpPr>
-        <p:spPr>
-          <a:xfrm>
-            <a:off x="4406051" y="6308727"/>
-            <a:ext cx="1169155" cy="485424"/>
-          </a:xfrm>
-          <a:prstGeom prst="rect">
-            <a:avLst/>
-          </a:prstGeom>
-        </p:spPr>
+        <p:spPr/>
         <p:txBody>
           <a:bodyPr/>
           <a:lstStyle/>
           <a:p>
-            <a:fld id="{19E4FA1D-83B2-3A4E-B175-FAA1598AB2F4}" type="datetimeFigureOut">
+            <a:fld id="{06398C8E-5F1F-264A-B7A5-192690BD161C}" type="datetime1">
               <a:rPr lang="en-US" smtClean="0"/>
-              <a:t>9/22/26</a:t>
+              <a:t>10/8/26</a:t>
             </a:fld>
             <a:endParaRPr lang="en-US"/>
           </a:p>
@@ -2119,7 +2276,13 @@
       </p:sp>
       <p:sp>
         <p:nvSpPr>
-          <p:cNvPr id="4" name="Footer Placeholder 3"/>
+          <p:cNvPr id="8" name="Footer Placeholder 7">
+            <a:extLst>
+              <a:ext uri="{FF2B5EF4-FFF2-40B4-BE49-F238E27FC236}">
+                <a16:creationId xmlns:a16="http://schemas.microsoft.com/office/drawing/2014/main" id="{3E733F8A-5589-31C8-DB78-246D75351B3B}"/>
+              </a:ext>
+            </a:extLst>
+          </p:cNvPr>
           <p:cNvSpPr>
             <a:spLocks noGrp="1"/>
           </p:cNvSpPr>
@@ -2132,13 +2295,22 @@
           <a:bodyPr/>
           <a:lstStyle/>
           <a:p>
-            <a:endParaRPr lang="en-US"/>
-          </a:p>
-        </p:txBody>
-      </p:sp>
-      <p:sp>
-        <p:nvSpPr>
-          <p:cNvPr id="5" name="Slide Number Placeholder 4"/>
+            <a:r>
+              <a:rPr lang="en-US"/>
+              <a:t>© Steve Beaty and others as cited</a:t>
+            </a:r>
+          </a:p>
+        </p:txBody>
+      </p:sp>
+      <p:sp>
+        <p:nvSpPr>
+          <p:cNvPr id="9" name="Slide Number Placeholder 8">
+            <a:extLst>
+              <a:ext uri="{FF2B5EF4-FFF2-40B4-BE49-F238E27FC236}">
+                <a16:creationId xmlns:a16="http://schemas.microsoft.com/office/drawing/2014/main" id="{CF4200DB-D3DA-2D0A-8CD3-6E48E32FC594}"/>
+              </a:ext>
+            </a:extLst>
+          </p:cNvPr>
           <p:cNvSpPr>
             <a:spLocks noGrp="1"/>
           </p:cNvSpPr>
@@ -2162,7 +2334,7 @@
     </p:spTree>
     <p:extLst>
       <p:ext uri="{BB962C8B-B14F-4D97-AF65-F5344CB8AC3E}">
-        <p14:creationId xmlns:p14="http://schemas.microsoft.com/office/powerpoint/2010/main" val="2902689797"/>
+        <p14:creationId xmlns:p14="http://schemas.microsoft.com/office/powerpoint/2010/main" val="443673141"/>
       </p:ext>
     </p:extLst>
   </p:cSld>
@@ -2171,12 +2343,12 @@
   </p:clrMapOvr>
   <mc:AlternateContent xmlns:mc="http://schemas.openxmlformats.org/markup-compatibility/2006" xmlns:p14="http://schemas.microsoft.com/office/powerpoint/2010/main">
     <mc:Choice Requires="p14">
-      <p:transition spd="slow" p14:dur="1200">
-        <p14:prism/>
+      <p:transition spd="slow" p14:dur="2000">
+        <p14:prism isContent="1"/>
       </p:transition>
     </mc:Choice>
     <mc:Fallback xmlns="">
-      <p:transition xmlns:p14="http://schemas.microsoft.com/office/powerpoint/2010/main" spd="slow">
+      <p:transition spd="slow">
         <p:fade/>
       </p:transition>
     </mc:Fallback>
@@ -2203,7 +2375,13 @@
       </p:grpSpPr>
       <p:sp>
         <p:nvSpPr>
-          <p:cNvPr id="3" name="Date Placeholder 2"/>
+          <p:cNvPr id="6" name="Date Placeholder 5">
+            <a:extLst>
+              <a:ext uri="{FF2B5EF4-FFF2-40B4-BE49-F238E27FC236}">
+                <a16:creationId xmlns:a16="http://schemas.microsoft.com/office/drawing/2014/main" id="{5C487D0D-A6BE-50D0-4804-465FF9AE0F65}"/>
+              </a:ext>
+            </a:extLst>
+          </p:cNvPr>
           <p:cNvSpPr>
             <a:spLocks noGrp="1"/>
           </p:cNvSpPr>
@@ -2211,22 +2389,14 @@
             <p:ph type="dt" sz="half" idx="10"/>
           </p:nvPr>
         </p:nvSpPr>
-        <p:spPr>
-          <a:xfrm>
-            <a:off x="4406051" y="6308727"/>
-            <a:ext cx="1169155" cy="485424"/>
-          </a:xfrm>
-          <a:prstGeom prst="rect">
-            <a:avLst/>
-          </a:prstGeom>
-        </p:spPr>
+        <p:spPr/>
         <p:txBody>
           <a:bodyPr/>
           <a:lstStyle/>
           <a:p>
-            <a:fld id="{19E4FA1D-83B2-3A4E-B175-FAA1598AB2F4}" type="datetimeFigureOut">
+            <a:fld id="{72AF1355-8BED-B940-B46D-02A9461AC1D0}" type="datetime1">
               <a:rPr lang="en-US" smtClean="0"/>
-              <a:t>9/22/26</a:t>
+              <a:t>10/8/26</a:t>
             </a:fld>
             <a:endParaRPr lang="en-US"/>
           </a:p>
@@ -2234,7 +2404,13 @@
       </p:sp>
       <p:sp>
         <p:nvSpPr>
-          <p:cNvPr id="4" name="Footer Placeholder 3"/>
+          <p:cNvPr id="7" name="Footer Placeholder 6">
+            <a:extLst>
+              <a:ext uri="{FF2B5EF4-FFF2-40B4-BE49-F238E27FC236}">
+                <a16:creationId xmlns:a16="http://schemas.microsoft.com/office/drawing/2014/main" id="{FF4343B0-C3EA-68AB-7293-4C580E1ED630}"/>
+              </a:ext>
+            </a:extLst>
+          </p:cNvPr>
           <p:cNvSpPr>
             <a:spLocks noGrp="1"/>
           </p:cNvSpPr>
@@ -2247,13 +2423,22 @@
           <a:bodyPr/>
           <a:lstStyle/>
           <a:p>
-            <a:endParaRPr lang="en-US"/>
-          </a:p>
-        </p:txBody>
-      </p:sp>
-      <p:sp>
-        <p:nvSpPr>
-          <p:cNvPr id="5" name="Slide Number Placeholder 4"/>
+            <a:r>
+              <a:rPr lang="en-US"/>
+              <a:t>© Steve Beaty and others as cited</a:t>
+            </a:r>
+          </a:p>
+        </p:txBody>
+      </p:sp>
+      <p:sp>
+        <p:nvSpPr>
+          <p:cNvPr id="8" name="Slide Number Placeholder 7">
+            <a:extLst>
+              <a:ext uri="{FF2B5EF4-FFF2-40B4-BE49-F238E27FC236}">
+                <a16:creationId xmlns:a16="http://schemas.microsoft.com/office/drawing/2014/main" id="{498496D9-0557-9109-1A11-35D97D8FDD5A}"/>
+              </a:ext>
+            </a:extLst>
+          </p:cNvPr>
           <p:cNvSpPr>
             <a:spLocks noGrp="1"/>
           </p:cNvSpPr>
@@ -2277,7 +2462,7 @@
     </p:spTree>
     <p:extLst>
       <p:ext uri="{BB962C8B-B14F-4D97-AF65-F5344CB8AC3E}">
-        <p14:creationId xmlns:p14="http://schemas.microsoft.com/office/powerpoint/2010/main" val="2642789126"/>
+        <p14:creationId xmlns:p14="http://schemas.microsoft.com/office/powerpoint/2010/main" val="1845842928"/>
       </p:ext>
     </p:extLst>
   </p:cSld>
@@ -2286,236 +2471,16 @@
   </p:clrMapOvr>
   <mc:AlternateContent xmlns:mc="http://schemas.openxmlformats.org/markup-compatibility/2006" xmlns:p14="http://schemas.microsoft.com/office/powerpoint/2010/main">
     <mc:Choice Requires="p14">
-      <p:transition spd="slow" p14:dur="1200">
-        <p14:prism/>
+      <p:transition spd="slow" p14:dur="2000">
+        <p14:prism isContent="1"/>
       </p:transition>
     </mc:Choice>
     <mc:Fallback xmlns="">
-      <p:transition xmlns:p14="http://schemas.microsoft.com/office/powerpoint/2010/main" spd="slow">
+      <p:transition spd="slow">
         <p:fade/>
       </p:transition>
     </mc:Fallback>
   </mc:AlternateContent>
-</p:sldLayout>
-</file>
-
-<file path=ppt/slideLayouts/slideLayout8.xml><?xml version="1.0" encoding="utf-8"?>
-<p:sldLayout xmlns:a="http://schemas.openxmlformats.org/drawingml/2006/main" xmlns:r="http://schemas.openxmlformats.org/officeDocument/2006/relationships" xmlns:p="http://schemas.openxmlformats.org/presentationml/2006/main" type="title">
-  <p:cSld name="1_Title Slide">
-    <p:spTree>
-      <p:nvGrpSpPr>
-        <p:cNvPr id="1" name=""/>
-        <p:cNvGrpSpPr/>
-        <p:nvPr/>
-      </p:nvGrpSpPr>
-      <p:grpSpPr>
-        <a:xfrm>
-          <a:off x="0" y="0"/>
-          <a:ext cx="0" cy="0"/>
-          <a:chOff x="0" y="0"/>
-          <a:chExt cx="0" cy="0"/>
-        </a:xfrm>
-      </p:grpSpPr>
-      <p:sp>
-        <p:nvSpPr>
-          <p:cNvPr id="2" name="Title 1">
-            <a:extLst>
-              <a:ext uri="{FF2B5EF4-FFF2-40B4-BE49-F238E27FC236}">
-                <a16:creationId xmlns:a16="http://schemas.microsoft.com/office/drawing/2014/main" id="{4E0B955B-3757-0FEC-8150-652A2829B605}"/>
-              </a:ext>
-            </a:extLst>
-          </p:cNvPr>
-          <p:cNvSpPr>
-            <a:spLocks noGrp="1"/>
-          </p:cNvSpPr>
-          <p:nvPr>
-            <p:ph type="ctrTitle"/>
-          </p:nvPr>
-        </p:nvSpPr>
-        <p:spPr>
-          <a:xfrm>
-            <a:off x="1524000" y="1122363"/>
-            <a:ext cx="9144000" cy="2387600"/>
-          </a:xfrm>
-        </p:spPr>
-        <p:txBody>
-          <a:bodyPr anchor="b"/>
-          <a:lstStyle>
-            <a:lvl1pPr algn="ctr">
-              <a:defRPr sz="6000"/>
-            </a:lvl1pPr>
-          </a:lstStyle>
-          <a:p>
-            <a:r>
-              <a:rPr lang="en-US"/>
-              <a:t>Click to edit Master title style</a:t>
-            </a:r>
-          </a:p>
-        </p:txBody>
-      </p:sp>
-      <p:sp>
-        <p:nvSpPr>
-          <p:cNvPr id="3" name="Subtitle 2">
-            <a:extLst>
-              <a:ext uri="{FF2B5EF4-FFF2-40B4-BE49-F238E27FC236}">
-                <a16:creationId xmlns:a16="http://schemas.microsoft.com/office/drawing/2014/main" id="{F4D276C4-C962-AF3D-11A5-8A6411774B25}"/>
-              </a:ext>
-            </a:extLst>
-          </p:cNvPr>
-          <p:cNvSpPr>
-            <a:spLocks noGrp="1"/>
-          </p:cNvSpPr>
-          <p:nvPr>
-            <p:ph type="subTitle" idx="1"/>
-          </p:nvPr>
-        </p:nvSpPr>
-        <p:spPr>
-          <a:xfrm>
-            <a:off x="1524000" y="3602038"/>
-            <a:ext cx="9144000" cy="1655762"/>
-          </a:xfrm>
-        </p:spPr>
-        <p:txBody>
-          <a:bodyPr/>
-          <a:lstStyle>
-            <a:lvl1pPr marL="0" indent="0" algn="ctr">
-              <a:buNone/>
-              <a:defRPr sz="2400"/>
-            </a:lvl1pPr>
-            <a:lvl2pPr marL="457200" indent="0" algn="ctr">
-              <a:buNone/>
-              <a:defRPr sz="2000"/>
-            </a:lvl2pPr>
-            <a:lvl3pPr marL="914400" indent="0" algn="ctr">
-              <a:buNone/>
-              <a:defRPr sz="1800"/>
-            </a:lvl3pPr>
-            <a:lvl4pPr marL="1371600" indent="0" algn="ctr">
-              <a:buNone/>
-              <a:defRPr sz="1600"/>
-            </a:lvl4pPr>
-            <a:lvl5pPr marL="1828800" indent="0" algn="ctr">
-              <a:buNone/>
-              <a:defRPr sz="1600"/>
-            </a:lvl5pPr>
-            <a:lvl6pPr marL="2286000" indent="0" algn="ctr">
-              <a:buNone/>
-              <a:defRPr sz="1600"/>
-            </a:lvl6pPr>
-            <a:lvl7pPr marL="2743200" indent="0" algn="ctr">
-              <a:buNone/>
-              <a:defRPr sz="1600"/>
-            </a:lvl7pPr>
-            <a:lvl8pPr marL="3200400" indent="0" algn="ctr">
-              <a:buNone/>
-              <a:defRPr sz="1600"/>
-            </a:lvl8pPr>
-            <a:lvl9pPr marL="3657600" indent="0" algn="ctr">
-              <a:buNone/>
-              <a:defRPr sz="1600"/>
-            </a:lvl9pPr>
-          </a:lstStyle>
-          <a:p>
-            <a:r>
-              <a:rPr lang="en-US"/>
-              <a:t>Click to edit Master subtitle style</a:t>
-            </a:r>
-          </a:p>
-        </p:txBody>
-      </p:sp>
-      <p:sp>
-        <p:nvSpPr>
-          <p:cNvPr id="4" name="Date Placeholder 3">
-            <a:extLst>
-              <a:ext uri="{FF2B5EF4-FFF2-40B4-BE49-F238E27FC236}">
-                <a16:creationId xmlns:a16="http://schemas.microsoft.com/office/drawing/2014/main" id="{E6323134-95A2-6423-76C0-9D75A168C984}"/>
-              </a:ext>
-            </a:extLst>
-          </p:cNvPr>
-          <p:cNvSpPr>
-            <a:spLocks noGrp="1"/>
-          </p:cNvSpPr>
-          <p:nvPr>
-            <p:ph type="dt" sz="half" idx="10"/>
-          </p:nvPr>
-        </p:nvSpPr>
-        <p:spPr/>
-        <p:txBody>
-          <a:bodyPr/>
-          <a:lstStyle/>
-          <a:p>
-            <a:fld id="{19E4FA1D-83B2-3A4E-B175-FAA1598AB2F4}" type="datetimeFigureOut">
-              <a:rPr lang="en-US" smtClean="0"/>
-              <a:t>9/22/26</a:t>
-            </a:fld>
-            <a:endParaRPr lang="en-US"/>
-          </a:p>
-        </p:txBody>
-      </p:sp>
-      <p:sp>
-        <p:nvSpPr>
-          <p:cNvPr id="5" name="Footer Placeholder 4">
-            <a:extLst>
-              <a:ext uri="{FF2B5EF4-FFF2-40B4-BE49-F238E27FC236}">
-                <a16:creationId xmlns:a16="http://schemas.microsoft.com/office/drawing/2014/main" id="{2419F5F4-E2F3-BFD8-53AA-6A6F195FC68B}"/>
-              </a:ext>
-            </a:extLst>
-          </p:cNvPr>
-          <p:cNvSpPr>
-            <a:spLocks noGrp="1"/>
-          </p:cNvSpPr>
-          <p:nvPr>
-            <p:ph type="ftr" sz="quarter" idx="11"/>
-          </p:nvPr>
-        </p:nvSpPr>
-        <p:spPr/>
-        <p:txBody>
-          <a:bodyPr/>
-          <a:lstStyle/>
-          <a:p>
-            <a:endParaRPr lang="en-US"/>
-          </a:p>
-        </p:txBody>
-      </p:sp>
-      <p:sp>
-        <p:nvSpPr>
-          <p:cNvPr id="6" name="Slide Number Placeholder 5">
-            <a:extLst>
-              <a:ext uri="{FF2B5EF4-FFF2-40B4-BE49-F238E27FC236}">
-                <a16:creationId xmlns:a16="http://schemas.microsoft.com/office/drawing/2014/main" id="{17B90BEB-A9D1-FF29-0E8C-A755B6F9863F}"/>
-              </a:ext>
-            </a:extLst>
-          </p:cNvPr>
-          <p:cNvSpPr>
-            <a:spLocks noGrp="1"/>
-          </p:cNvSpPr>
-          <p:nvPr>
-            <p:ph type="sldNum" sz="quarter" idx="12"/>
-          </p:nvPr>
-        </p:nvSpPr>
-        <p:spPr/>
-        <p:txBody>
-          <a:bodyPr/>
-          <a:lstStyle/>
-          <a:p>
-            <a:fld id="{DF323A44-C1E5-0B49-AAF6-7E9549B7BFD2}" type="slidenum">
-              <a:rPr lang="en-US" smtClean="0"/>
-              <a:t>‹#›</a:t>
-            </a:fld>
-            <a:endParaRPr lang="en-US"/>
-          </a:p>
-        </p:txBody>
-      </p:sp>
-    </p:spTree>
-    <p:extLst>
-      <p:ext uri="{BB962C8B-B14F-4D97-AF65-F5344CB8AC3E}">
-        <p14:creationId xmlns:p14="http://schemas.microsoft.com/office/powerpoint/2010/main" val="1583837719"/>
-      </p:ext>
-    </p:extLst>
-  </p:cSld>
-  <p:clrMapOvr>
-    <a:masterClrMapping/>
-  </p:clrMapOvr>
 </p:sldLayout>
 </file>
 
@@ -2525,7 +2490,7 @@
     <p:bg>
       <p:bgPr>
         <a:blipFill dpi="0" rotWithShape="1">
-          <a:blip r:embed="rId10">
+          <a:blip r:embed="rId9">
             <a:lum/>
           </a:blip>
           <a:srcRect/>
@@ -2565,8 +2530,10 @@
             <a:off x="609600" y="274639"/>
             <a:ext cx="10972800" cy="1143000"/>
           </a:xfrm>
-          <a:prstGeom prst="rect">
-            <a:avLst/>
+          <a:prstGeom prst="roundRect">
+            <a:avLst>
+              <a:gd name="adj" fmla="val 44167"/>
+            </a:avLst>
           </a:prstGeom>
           <a:solidFill>
             <a:schemeClr val="bg1">
@@ -2613,7 +2580,7 @@
             <a:off x="609600" y="1600201"/>
             <a:ext cx="10972800" cy="4525963"/>
           </a:xfrm>
-          <a:prstGeom prst="rect">
+          <a:prstGeom prst="roundRect">
             <a:avLst/>
           </a:prstGeom>
           <a:solidFill>
@@ -2687,11 +2654,13 @@
         </p:nvSpPr>
         <p:spPr>
           <a:xfrm>
-            <a:off x="1596887" y="6309418"/>
-            <a:ext cx="8998226" cy="487680"/>
+            <a:off x="1881809" y="6308727"/>
+            <a:ext cx="7945363" cy="487680"/>
           </a:xfrm>
-          <a:prstGeom prst="rect">
-            <a:avLst/>
+          <a:prstGeom prst="roundRect">
+            <a:avLst>
+              <a:gd name="adj" fmla="val 48894"/>
+            </a:avLst>
           </a:prstGeom>
           <a:solidFill>
             <a:schemeClr val="bg1"/>
@@ -2712,7 +2681,10 @@
             </a:lvl1pPr>
           </a:lstStyle>
           <a:p>
-            <a:endParaRPr lang="en-US"/>
+            <a:r>
+              <a:rPr lang="en-US"/>
+              <a:t>© Steve Beaty and others as cited</a:t>
+            </a:r>
           </a:p>
         </p:txBody>
       </p:sp>
@@ -2728,11 +2700,13 @@
         </p:nvSpPr>
         <p:spPr>
           <a:xfrm>
-            <a:off x="10702624" y="6308727"/>
+            <a:off x="9934686" y="6308727"/>
             <a:ext cx="879777" cy="487680"/>
           </a:xfrm>
-          <a:prstGeom prst="rect">
-            <a:avLst/>
+          <a:prstGeom prst="roundRect">
+            <a:avLst>
+              <a:gd name="adj" fmla="val 43034"/>
+            </a:avLst>
           </a:prstGeom>
           <a:solidFill>
             <a:schemeClr val="bg1"/>
@@ -2744,7 +2718,7 @@
         <p:txBody>
           <a:bodyPr vert="horz" lIns="91440" tIns="45720" rIns="91440" bIns="45720" rtlCol="0" anchor="ctr"/>
           <a:lstStyle>
-            <a:lvl1pPr algn="r">
+            <a:lvl1pPr algn="ctr">
               <a:defRPr sz="1600">
                 <a:solidFill>
                   <a:schemeClr val="tx1">
@@ -2763,23 +2737,210 @@
           </a:p>
         </p:txBody>
       </p:sp>
+      <p:sp>
+        <p:nvSpPr>
+          <p:cNvPr id="4" name="Date Placeholder 2">
+            <a:extLst>
+              <a:ext uri="{FF2B5EF4-FFF2-40B4-BE49-F238E27FC236}">
+                <a16:creationId xmlns:a16="http://schemas.microsoft.com/office/drawing/2014/main" id="{B6740CB2-DC30-5DDB-24B8-219C9C3F5967}"/>
+              </a:ext>
+            </a:extLst>
+          </p:cNvPr>
+          <p:cNvSpPr>
+            <a:spLocks noGrp="1"/>
+          </p:cNvSpPr>
+          <p:nvPr>
+            <p:ph type="dt" sz="half" idx="2"/>
+          </p:nvPr>
+        </p:nvSpPr>
+        <p:spPr>
+          <a:xfrm>
+            <a:off x="605141" y="6308727"/>
+            <a:ext cx="1169155" cy="487680"/>
+          </a:xfrm>
+          <a:prstGeom prst="roundRect">
+            <a:avLst>
+              <a:gd name="adj" fmla="val 48894"/>
+            </a:avLst>
+          </a:prstGeom>
+          <a:solidFill>
+            <a:schemeClr val="bg1"/>
+          </a:solidFill>
+          <a:effectLst>
+            <a:softEdge rad="63500"/>
+          </a:effectLst>
+        </p:spPr>
+        <p:txBody>
+          <a:bodyPr anchor="ctr" anchorCtr="0"/>
+          <a:lstStyle>
+            <a:lvl1pPr algn="ctr">
+              <a:defRPr sz="1600"/>
+            </a:lvl1pPr>
+          </a:lstStyle>
+          <a:p>
+            <a:fld id="{E9EDF633-B6FA-6744-8F1E-B577B0EE3828}" type="datetime1">
+              <a:rPr lang="en-US" smtClean="0"/>
+              <a:t>10/8/26</a:t>
+            </a:fld>
+            <a:endParaRPr lang="en-US"/>
+          </a:p>
+        </p:txBody>
+      </p:sp>
+      <p:sp>
+        <p:nvSpPr>
+          <p:cNvPr id="7" name="SlideTotal">
+            <a:extLst>
+              <a:ext uri="{FF2B5EF4-FFF2-40B4-BE49-F238E27FC236}">
+                <a16:creationId xmlns:a16="http://schemas.microsoft.com/office/drawing/2014/main" id="{B74D5B4B-3C60-FF6A-4438-A067B7DE7333}"/>
+              </a:ext>
+            </a:extLst>
+          </p:cNvPr>
+          <p:cNvSpPr txBox="1">
+            <a:spLocks/>
+          </p:cNvSpPr>
+          <p:nvPr/>
+        </p:nvSpPr>
+        <p:spPr>
+          <a:xfrm>
+            <a:off x="10702624" y="6308727"/>
+            <a:ext cx="879777" cy="487680"/>
+          </a:xfrm>
+          <a:prstGeom prst="roundRect">
+            <a:avLst>
+              <a:gd name="adj" fmla="val 43034"/>
+            </a:avLst>
+          </a:prstGeom>
+          <a:solidFill>
+            <a:schemeClr val="bg1"/>
+          </a:solidFill>
+          <a:effectLst>
+            <a:softEdge rad="63500"/>
+          </a:effectLst>
+        </p:spPr>
+        <p:txBody>
+          <a:bodyPr vert="horz" lIns="121920" tIns="60960" rIns="121920" bIns="60960" rtlCol="0" anchor="ctr"/>
+          <a:lstStyle>
+            <a:defPPr>
+              <a:defRPr lang="en-US"/>
+            </a:defPPr>
+            <a:lvl1pPr marL="0" algn="ctr" defTabSz="914400" rtl="0" eaLnBrk="1" latinLnBrk="0" hangingPunct="1">
+              <a:defRPr sz="1200" kern="1200">
+                <a:solidFill>
+                  <a:schemeClr val="tx1">
+                    <a:tint val="75000"/>
+                  </a:schemeClr>
+                </a:solidFill>
+                <a:latin typeface="+mn-lt"/>
+                <a:ea typeface="+mn-ea"/>
+                <a:cs typeface="+mn-cs"/>
+              </a:defRPr>
+            </a:lvl1pPr>
+            <a:lvl2pPr marL="457200" algn="l" defTabSz="914400" rtl="0" eaLnBrk="1" latinLnBrk="0" hangingPunct="1">
+              <a:defRPr sz="1800" kern="1200">
+                <a:solidFill>
+                  <a:schemeClr val="tx1"/>
+                </a:solidFill>
+                <a:latin typeface="+mn-lt"/>
+                <a:ea typeface="+mn-ea"/>
+                <a:cs typeface="+mn-cs"/>
+              </a:defRPr>
+            </a:lvl2pPr>
+            <a:lvl3pPr marL="914400" algn="l" defTabSz="914400" rtl="0" eaLnBrk="1" latinLnBrk="0" hangingPunct="1">
+              <a:defRPr sz="1800" kern="1200">
+                <a:solidFill>
+                  <a:schemeClr val="tx1"/>
+                </a:solidFill>
+                <a:latin typeface="+mn-lt"/>
+                <a:ea typeface="+mn-ea"/>
+                <a:cs typeface="+mn-cs"/>
+              </a:defRPr>
+            </a:lvl3pPr>
+            <a:lvl4pPr marL="1371600" algn="l" defTabSz="914400" rtl="0" eaLnBrk="1" latinLnBrk="0" hangingPunct="1">
+              <a:defRPr sz="1800" kern="1200">
+                <a:solidFill>
+                  <a:schemeClr val="tx1"/>
+                </a:solidFill>
+                <a:latin typeface="+mn-lt"/>
+                <a:ea typeface="+mn-ea"/>
+                <a:cs typeface="+mn-cs"/>
+              </a:defRPr>
+            </a:lvl4pPr>
+            <a:lvl5pPr marL="1828800" algn="l" defTabSz="914400" rtl="0" eaLnBrk="1" latinLnBrk="0" hangingPunct="1">
+              <a:defRPr sz="1800" kern="1200">
+                <a:solidFill>
+                  <a:schemeClr val="tx1"/>
+                </a:solidFill>
+                <a:latin typeface="+mn-lt"/>
+                <a:ea typeface="+mn-ea"/>
+                <a:cs typeface="+mn-cs"/>
+              </a:defRPr>
+            </a:lvl5pPr>
+            <a:lvl6pPr marL="2286000" algn="l" defTabSz="914400" rtl="0" eaLnBrk="1" latinLnBrk="0" hangingPunct="1">
+              <a:defRPr sz="1800" kern="1200">
+                <a:solidFill>
+                  <a:schemeClr val="tx1"/>
+                </a:solidFill>
+                <a:latin typeface="+mn-lt"/>
+                <a:ea typeface="+mn-ea"/>
+                <a:cs typeface="+mn-cs"/>
+              </a:defRPr>
+            </a:lvl6pPr>
+            <a:lvl7pPr marL="2743200" algn="l" defTabSz="914400" rtl="0" eaLnBrk="1" latinLnBrk="0" hangingPunct="1">
+              <a:defRPr sz="1800" kern="1200">
+                <a:solidFill>
+                  <a:schemeClr val="tx1"/>
+                </a:solidFill>
+                <a:latin typeface="+mn-lt"/>
+                <a:ea typeface="+mn-ea"/>
+                <a:cs typeface="+mn-cs"/>
+              </a:defRPr>
+            </a:lvl7pPr>
+            <a:lvl8pPr marL="3200400" algn="l" defTabSz="914400" rtl="0" eaLnBrk="1" latinLnBrk="0" hangingPunct="1">
+              <a:defRPr sz="1800" kern="1200">
+                <a:solidFill>
+                  <a:schemeClr val="tx1"/>
+                </a:solidFill>
+                <a:latin typeface="+mn-lt"/>
+                <a:ea typeface="+mn-ea"/>
+                <a:cs typeface="+mn-cs"/>
+              </a:defRPr>
+            </a:lvl8pPr>
+            <a:lvl9pPr marL="3657600" algn="l" defTabSz="914400" rtl="0" eaLnBrk="1" latinLnBrk="0" hangingPunct="1">
+              <a:defRPr sz="1800" kern="1200">
+                <a:solidFill>
+                  <a:schemeClr val="tx1"/>
+                </a:solidFill>
+                <a:latin typeface="+mn-lt"/>
+                <a:ea typeface="+mn-ea"/>
+                <a:cs typeface="+mn-cs"/>
+              </a:defRPr>
+            </a:lvl9pPr>
+          </a:lstStyle>
+          <a:p>
+            <a:r>
+              <a:rPr lang="en-US" sz="1600"/>
+              <a:t>26</a:t>
+            </a:r>
+            <a:endParaRPr lang="en-US" sz="1600" dirty="0"/>
+          </a:p>
+        </p:txBody>
+      </p:sp>
     </p:spTree>
     <p:extLst>
       <p:ext uri="{BB962C8B-B14F-4D97-AF65-F5344CB8AC3E}">
-        <p14:creationId xmlns:p14="http://schemas.microsoft.com/office/powerpoint/2010/main" val="3168088356"/>
+        <p14:creationId xmlns:p14="http://schemas.microsoft.com/office/powerpoint/2010/main" val="271659408"/>
       </p:ext>
     </p:extLst>
   </p:cSld>
   <p:clrMap bg1="lt1" tx1="dk1" bg2="lt2" tx2="dk2" accent1="accent1" accent2="accent2" accent3="accent3" accent4="accent4" accent5="accent5" accent6="accent6" hlink="hlink" folHlink="folHlink"/>
   <p:sldLayoutIdLst>
-    <p:sldLayoutId id="2147483661" r:id="rId1"/>
-    <p:sldLayoutId id="2147483662" r:id="rId2"/>
-    <p:sldLayoutId id="2147483663" r:id="rId3"/>
-    <p:sldLayoutId id="2147483664" r:id="rId4"/>
-    <p:sldLayoutId id="2147483665" r:id="rId5"/>
-    <p:sldLayoutId id="2147483666" r:id="rId6"/>
-    <p:sldLayoutId id="2147483667" r:id="rId7"/>
-    <p:sldLayoutId id="2147483668" r:id="rId8"/>
+    <p:sldLayoutId id="2147483670" r:id="rId1"/>
+    <p:sldLayoutId id="2147483671" r:id="rId2"/>
+    <p:sldLayoutId id="2147483672" r:id="rId3"/>
+    <p:sldLayoutId id="2147483673" r:id="rId4"/>
+    <p:sldLayoutId id="2147483674" r:id="rId5"/>
+    <p:sldLayoutId id="2147483675" r:id="rId6"/>
+    <p:sldLayoutId id="2147483676" r:id="rId7"/>
   </p:sldLayoutIdLst>
   <mc:AlternateContent xmlns:mc="http://schemas.openxmlformats.org/markup-compatibility/2006" xmlns:p14="http://schemas.microsoft.com/office/powerpoint/2010/main">
     <mc:Choice Requires="p14">
@@ -2793,9 +2954,10 @@
       </p:transition>
     </mc:Fallback>
   </mc:AlternateContent>
+  <p:hf hdr="0"/>
   <p:txStyles>
     <p:titleStyle>
-      <a:lvl1pPr algn="ctr" defTabSz="609570" rtl="0" eaLnBrk="1" latinLnBrk="0" hangingPunct="1">
+      <a:lvl1pPr algn="ctr" defTabSz="609555" rtl="0" eaLnBrk="1" latinLnBrk="0" hangingPunct="1">
         <a:spcBef>
           <a:spcPct val="0"/>
         </a:spcBef>
@@ -2811,7 +2973,7 @@
       </a:lvl1pPr>
     </p:titleStyle>
     <p:bodyStyle>
-      <a:lvl1pPr marL="457177" indent="-457177" algn="l" defTabSz="609570" rtl="0" eaLnBrk="1" latinLnBrk="0" hangingPunct="1">
+      <a:lvl1pPr marL="457166" indent="-457166" algn="l" defTabSz="609555" rtl="0" eaLnBrk="1" latinLnBrk="0" hangingPunct="1">
         <a:spcBef>
           <a:spcPct val="20000"/>
         </a:spcBef>
@@ -2826,7 +2988,7 @@
           <a:cs typeface="+mn-cs"/>
         </a:defRPr>
       </a:lvl1pPr>
-      <a:lvl2pPr marL="990551" indent="-380982" algn="l" defTabSz="609570" rtl="0" eaLnBrk="1" latinLnBrk="0" hangingPunct="1">
+      <a:lvl2pPr marL="990526" indent="-380973" algn="l" defTabSz="609555" rtl="0" eaLnBrk="1" latinLnBrk="0" hangingPunct="1">
         <a:spcBef>
           <a:spcPct val="20000"/>
         </a:spcBef>
@@ -2841,7 +3003,7 @@
           <a:cs typeface="+mn-cs"/>
         </a:defRPr>
       </a:lvl2pPr>
-      <a:lvl3pPr marL="1523923" indent="-304784" algn="l" defTabSz="609570" rtl="0" eaLnBrk="1" latinLnBrk="0" hangingPunct="1">
+      <a:lvl3pPr marL="1523885" indent="-304776" algn="l" defTabSz="609555" rtl="0" eaLnBrk="1" latinLnBrk="0" hangingPunct="1">
         <a:spcBef>
           <a:spcPct val="20000"/>
         </a:spcBef>
@@ -2856,7 +3018,7 @@
           <a:cs typeface="+mn-cs"/>
         </a:defRPr>
       </a:lvl3pPr>
-      <a:lvl4pPr marL="2133493" indent="-304784" algn="l" defTabSz="609570" rtl="0" eaLnBrk="1" latinLnBrk="0" hangingPunct="1">
+      <a:lvl4pPr marL="2133440" indent="-304776" algn="l" defTabSz="609555" rtl="0" eaLnBrk="1" latinLnBrk="0" hangingPunct="1">
         <a:spcBef>
           <a:spcPct val="20000"/>
         </a:spcBef>
@@ -2871,7 +3033,7 @@
           <a:cs typeface="+mn-cs"/>
         </a:defRPr>
       </a:lvl4pPr>
-      <a:lvl5pPr marL="2743063" indent="-304784" algn="l" defTabSz="609570" rtl="0" eaLnBrk="1" latinLnBrk="0" hangingPunct="1">
+      <a:lvl5pPr marL="2742994" indent="-304776" algn="l" defTabSz="609555" rtl="0" eaLnBrk="1" latinLnBrk="0" hangingPunct="1">
         <a:spcBef>
           <a:spcPct val="20000"/>
         </a:spcBef>
@@ -2886,7 +3048,7 @@
           <a:cs typeface="+mn-cs"/>
         </a:defRPr>
       </a:lvl5pPr>
-      <a:lvl6pPr marL="3352632" indent="-304784" algn="l" defTabSz="609570" rtl="0" eaLnBrk="1" latinLnBrk="0" hangingPunct="1">
+      <a:lvl6pPr marL="3352548" indent="-304776" algn="l" defTabSz="609555" rtl="0" eaLnBrk="1" latinLnBrk="0" hangingPunct="1">
         <a:spcBef>
           <a:spcPct val="20000"/>
         </a:spcBef>
@@ -2901,7 +3063,7 @@
           <a:cs typeface="+mn-cs"/>
         </a:defRPr>
       </a:lvl6pPr>
-      <a:lvl7pPr marL="3962202" indent="-304784" algn="l" defTabSz="609570" rtl="0" eaLnBrk="1" latinLnBrk="0" hangingPunct="1">
+      <a:lvl7pPr marL="3962104" indent="-304776" algn="l" defTabSz="609555" rtl="0" eaLnBrk="1" latinLnBrk="0" hangingPunct="1">
         <a:spcBef>
           <a:spcPct val="20000"/>
         </a:spcBef>
@@ -2916,7 +3078,7 @@
           <a:cs typeface="+mn-cs"/>
         </a:defRPr>
       </a:lvl7pPr>
-      <a:lvl8pPr marL="4571771" indent="-304784" algn="l" defTabSz="609570" rtl="0" eaLnBrk="1" latinLnBrk="0" hangingPunct="1">
+      <a:lvl8pPr marL="4571656" indent="-304776" algn="l" defTabSz="609555" rtl="0" eaLnBrk="1" latinLnBrk="0" hangingPunct="1">
         <a:spcBef>
           <a:spcPct val="20000"/>
         </a:spcBef>
@@ -2931,7 +3093,7 @@
           <a:cs typeface="+mn-cs"/>
         </a:defRPr>
       </a:lvl8pPr>
-      <a:lvl9pPr marL="5181341" indent="-304784" algn="l" defTabSz="609570" rtl="0" eaLnBrk="1" latinLnBrk="0" hangingPunct="1">
+      <a:lvl9pPr marL="5181212" indent="-304776" algn="l" defTabSz="609555" rtl="0" eaLnBrk="1" latinLnBrk="0" hangingPunct="1">
         <a:spcBef>
           <a:spcPct val="20000"/>
         </a:spcBef>
@@ -2951,7 +3113,7 @@
       <a:defPPr>
         <a:defRPr lang="en-US"/>
       </a:defPPr>
-      <a:lvl1pPr marL="0" algn="l" defTabSz="609570" rtl="0" eaLnBrk="1" latinLnBrk="0" hangingPunct="1">
+      <a:lvl1pPr marL="0" algn="l" defTabSz="609555" rtl="0" eaLnBrk="1" latinLnBrk="0" hangingPunct="1">
         <a:defRPr sz="2400" kern="1200">
           <a:solidFill>
             <a:schemeClr val="tx1"/>
@@ -2961,7 +3123,7 @@
           <a:cs typeface="+mn-cs"/>
         </a:defRPr>
       </a:lvl1pPr>
-      <a:lvl2pPr marL="609570" algn="l" defTabSz="609570" rtl="0" eaLnBrk="1" latinLnBrk="0" hangingPunct="1">
+      <a:lvl2pPr marL="609555" algn="l" defTabSz="609555" rtl="0" eaLnBrk="1" latinLnBrk="0" hangingPunct="1">
         <a:defRPr sz="2400" kern="1200">
           <a:solidFill>
             <a:schemeClr val="tx1"/>
@@ -2971,7 +3133,7 @@
           <a:cs typeface="+mn-cs"/>
         </a:defRPr>
       </a:lvl2pPr>
-      <a:lvl3pPr marL="1219139" algn="l" defTabSz="609570" rtl="0" eaLnBrk="1" latinLnBrk="0" hangingPunct="1">
+      <a:lvl3pPr marL="1219108" algn="l" defTabSz="609555" rtl="0" eaLnBrk="1" latinLnBrk="0" hangingPunct="1">
         <a:defRPr sz="2400" kern="1200">
           <a:solidFill>
             <a:schemeClr val="tx1"/>
@@ -2981,7 +3143,7 @@
           <a:cs typeface="+mn-cs"/>
         </a:defRPr>
       </a:lvl3pPr>
-      <a:lvl4pPr marL="1828709" algn="l" defTabSz="609570" rtl="0" eaLnBrk="1" latinLnBrk="0" hangingPunct="1">
+      <a:lvl4pPr marL="1828664" algn="l" defTabSz="609555" rtl="0" eaLnBrk="1" latinLnBrk="0" hangingPunct="1">
         <a:defRPr sz="2400" kern="1200">
           <a:solidFill>
             <a:schemeClr val="tx1"/>
@@ -2991,7 +3153,7 @@
           <a:cs typeface="+mn-cs"/>
         </a:defRPr>
       </a:lvl4pPr>
-      <a:lvl5pPr marL="2438278" algn="l" defTabSz="609570" rtl="0" eaLnBrk="1" latinLnBrk="0" hangingPunct="1">
+      <a:lvl5pPr marL="2438218" algn="l" defTabSz="609555" rtl="0" eaLnBrk="1" latinLnBrk="0" hangingPunct="1">
         <a:defRPr sz="2400" kern="1200">
           <a:solidFill>
             <a:schemeClr val="tx1"/>
@@ -3001,7 +3163,7 @@
           <a:cs typeface="+mn-cs"/>
         </a:defRPr>
       </a:lvl5pPr>
-      <a:lvl6pPr marL="3047848" algn="l" defTabSz="609570" rtl="0" eaLnBrk="1" latinLnBrk="0" hangingPunct="1">
+      <a:lvl6pPr marL="3047772" algn="l" defTabSz="609555" rtl="0" eaLnBrk="1" latinLnBrk="0" hangingPunct="1">
         <a:defRPr sz="2400" kern="1200">
           <a:solidFill>
             <a:schemeClr val="tx1"/>
@@ -3011,7 +3173,7 @@
           <a:cs typeface="+mn-cs"/>
         </a:defRPr>
       </a:lvl6pPr>
-      <a:lvl7pPr marL="3657417" algn="l" defTabSz="609570" rtl="0" eaLnBrk="1" latinLnBrk="0" hangingPunct="1">
+      <a:lvl7pPr marL="3657326" algn="l" defTabSz="609555" rtl="0" eaLnBrk="1" latinLnBrk="0" hangingPunct="1">
         <a:defRPr sz="2400" kern="1200">
           <a:solidFill>
             <a:schemeClr val="tx1"/>
@@ -3021,7 +3183,7 @@
           <a:cs typeface="+mn-cs"/>
         </a:defRPr>
       </a:lvl7pPr>
-      <a:lvl8pPr marL="4266987" algn="l" defTabSz="609570" rtl="0" eaLnBrk="1" latinLnBrk="0" hangingPunct="1">
+      <a:lvl8pPr marL="4266880" algn="l" defTabSz="609555" rtl="0" eaLnBrk="1" latinLnBrk="0" hangingPunct="1">
         <a:defRPr sz="2400" kern="1200">
           <a:solidFill>
             <a:schemeClr val="tx1"/>
@@ -3031,7 +3193,7 @@
           <a:cs typeface="+mn-cs"/>
         </a:defRPr>
       </a:lvl8pPr>
-      <a:lvl9pPr marL="4876557" algn="l" defTabSz="609570" rtl="0" eaLnBrk="1" latinLnBrk="0" hangingPunct="1">
+      <a:lvl9pPr marL="4876435" algn="l" defTabSz="609555" rtl="0" eaLnBrk="1" latinLnBrk="0" hangingPunct="1">
         <a:defRPr sz="2400" kern="1200">
           <a:solidFill>
             <a:schemeClr val="tx1"/>
@@ -3116,6 +3278,94 @@
           </a:p>
         </p:txBody>
       </p:sp>
+      <p:sp>
+        <p:nvSpPr>
+          <p:cNvPr id="2" name="Date Placeholder 1">
+            <a:extLst>
+              <a:ext uri="{FF2B5EF4-FFF2-40B4-BE49-F238E27FC236}">
+                <a16:creationId xmlns:a16="http://schemas.microsoft.com/office/drawing/2014/main" id="{CC35F63D-6122-EB8C-0F14-C7C5D38DE8EA}"/>
+              </a:ext>
+            </a:extLst>
+          </p:cNvPr>
+          <p:cNvSpPr>
+            <a:spLocks noGrp="1"/>
+          </p:cNvSpPr>
+          <p:nvPr>
+            <p:ph type="dt" sz="half" idx="11"/>
+          </p:nvPr>
+        </p:nvSpPr>
+        <p:spPr/>
+        <p:txBody>
+          <a:bodyPr/>
+          <a:lstStyle/>
+          <a:p>
+            <a:fld id="{3FE51F0F-724C-5B4F-85F3-E46C0190DCB8}" type="datetime1">
+              <a:rPr lang="en-US" smtClean="0"/>
+              <a:t>10/8/26</a:t>
+            </a:fld>
+            <a:endParaRPr lang="en-US" dirty="0"/>
+          </a:p>
+        </p:txBody>
+      </p:sp>
+      <p:sp>
+        <p:nvSpPr>
+          <p:cNvPr id="3" name="Footer Placeholder 2">
+            <a:extLst>
+              <a:ext uri="{FF2B5EF4-FFF2-40B4-BE49-F238E27FC236}">
+                <a16:creationId xmlns:a16="http://schemas.microsoft.com/office/drawing/2014/main" id="{3FF264AF-C26D-3480-7EAC-61A34180A0A2}"/>
+              </a:ext>
+            </a:extLst>
+          </p:cNvPr>
+          <p:cNvSpPr>
+            <a:spLocks noGrp="1"/>
+          </p:cNvSpPr>
+          <p:nvPr>
+            <p:ph type="ftr" sz="quarter" idx="12"/>
+          </p:nvPr>
+        </p:nvSpPr>
+        <p:spPr/>
+        <p:txBody>
+          <a:bodyPr/>
+          <a:lstStyle/>
+          <a:p>
+            <a:r>
+              <a:rPr lang="en-US"/>
+              <a:t>© Steve Beaty and others as cited</a:t>
+            </a:r>
+            <a:endParaRPr lang="en-US" dirty="0"/>
+          </a:p>
+        </p:txBody>
+      </p:sp>
+      <p:sp>
+        <p:nvSpPr>
+          <p:cNvPr id="6" name="Slide Number Placeholder 5">
+            <a:extLst>
+              <a:ext uri="{FF2B5EF4-FFF2-40B4-BE49-F238E27FC236}">
+                <a16:creationId xmlns:a16="http://schemas.microsoft.com/office/drawing/2014/main" id="{799D9346-ECB8-2796-FBE7-FD676640D4D8}"/>
+              </a:ext>
+            </a:extLst>
+          </p:cNvPr>
+          <p:cNvSpPr>
+            <a:spLocks noGrp="1"/>
+          </p:cNvSpPr>
+          <p:nvPr>
+            <p:ph type="sldNum" sz="quarter" idx="13"/>
+          </p:nvPr>
+        </p:nvSpPr>
+        <p:spPr/>
+        <p:txBody>
+          <a:bodyPr/>
+          <a:lstStyle/>
+          <a:p>
+            <a:fld id="{37D050C8-32A2-8944-BC0A-E76DEAECED1E}" type="slidenum">
+              <a:rPr lang="en-US" smtClean="0"/>
+              <a:pPr/>
+              <a:t>1</a:t>
+            </a:fld>
+            <a:endParaRPr lang="en-US" dirty="0"/>
+          </a:p>
+        </p:txBody>
+      </p:sp>
     </p:spTree>
     <p:extLst>
       <p:ext uri="{BB962C8B-B14F-4D97-AF65-F5344CB8AC3E}">
@@ -3128,12 +3378,12 @@
   </p:clrMapOvr>
   <mc:AlternateContent xmlns:mc="http://schemas.openxmlformats.org/markup-compatibility/2006" xmlns:p14="http://schemas.microsoft.com/office/powerpoint/2010/main">
     <mc:Choice Requires="p14">
-      <p:transition spd="slow" p14:dur="1200">
-        <p14:prism/>
+      <p:transition spd="slow" p14:dur="2000">
+        <p14:prism isContent="1"/>
       </p:transition>
     </mc:Choice>
     <mc:Fallback xmlns="">
-      <p:transition xmlns:p14="http://schemas.microsoft.com/office/powerpoint/2010/main" spd="slow">
+      <p:transition spd="slow">
         <p:fade/>
       </p:transition>
     </mc:Fallback>
@@ -3176,7 +3426,9 @@
         </p:nvSpPr>
         <p:spPr/>
         <p:txBody>
-          <a:bodyPr/>
+          <a:bodyPr>
+            <a:normAutofit fontScale="90000"/>
+          </a:bodyPr>
           <a:lstStyle/>
           <a:p>
             <a:r>
@@ -3205,7 +3457,7 @@
         <p:spPr/>
         <p:txBody>
           <a:bodyPr>
-            <a:normAutofit fontScale="92500" lnSpcReduction="20000"/>
+            <a:normAutofit fontScale="85000" lnSpcReduction="20000"/>
           </a:bodyPr>
           <a:lstStyle/>
           <a:p>
@@ -3295,6 +3547,92 @@
               </a:rPr>
               <a:t>Keep in mind Ruby’s methods do not require parentheses</a:t>
             </a:r>
+          </a:p>
+        </p:txBody>
+      </p:sp>
+      <p:sp>
+        <p:nvSpPr>
+          <p:cNvPr id="4" name="Date Placeholder 3">
+            <a:extLst>
+              <a:ext uri="{FF2B5EF4-FFF2-40B4-BE49-F238E27FC236}">
+                <a16:creationId xmlns:a16="http://schemas.microsoft.com/office/drawing/2014/main" id="{A93D28F0-E48F-7F71-F417-CD323443C6F1}"/>
+              </a:ext>
+            </a:extLst>
+          </p:cNvPr>
+          <p:cNvSpPr>
+            <a:spLocks noGrp="1"/>
+          </p:cNvSpPr>
+          <p:nvPr>
+            <p:ph type="dt" sz="half" idx="10"/>
+          </p:nvPr>
+        </p:nvSpPr>
+        <p:spPr/>
+        <p:txBody>
+          <a:bodyPr/>
+          <a:lstStyle/>
+          <a:p>
+            <a:fld id="{25972DC4-3A3E-F143-86A9-9C524B69A913}" type="datetime1">
+              <a:rPr lang="en-US" smtClean="0"/>
+              <a:t>10/8/26</a:t>
+            </a:fld>
+            <a:endParaRPr lang="en-US"/>
+          </a:p>
+        </p:txBody>
+      </p:sp>
+      <p:sp>
+        <p:nvSpPr>
+          <p:cNvPr id="5" name="Footer Placeholder 4">
+            <a:extLst>
+              <a:ext uri="{FF2B5EF4-FFF2-40B4-BE49-F238E27FC236}">
+                <a16:creationId xmlns:a16="http://schemas.microsoft.com/office/drawing/2014/main" id="{3B404BB6-6222-72F0-49D7-9B62AD43CD58}"/>
+              </a:ext>
+            </a:extLst>
+          </p:cNvPr>
+          <p:cNvSpPr>
+            <a:spLocks noGrp="1"/>
+          </p:cNvSpPr>
+          <p:nvPr>
+            <p:ph type="ftr" sz="quarter" idx="11"/>
+          </p:nvPr>
+        </p:nvSpPr>
+        <p:spPr/>
+        <p:txBody>
+          <a:bodyPr/>
+          <a:lstStyle/>
+          <a:p>
+            <a:r>
+              <a:rPr lang="en-US"/>
+              <a:t>© Steve Beaty and others as cited</a:t>
+            </a:r>
+          </a:p>
+        </p:txBody>
+      </p:sp>
+      <p:sp>
+        <p:nvSpPr>
+          <p:cNvPr id="6" name="Slide Number Placeholder 5">
+            <a:extLst>
+              <a:ext uri="{FF2B5EF4-FFF2-40B4-BE49-F238E27FC236}">
+                <a16:creationId xmlns:a16="http://schemas.microsoft.com/office/drawing/2014/main" id="{2ECDF0F1-B6D8-4586-BDDE-A659EC425D37}"/>
+              </a:ext>
+            </a:extLst>
+          </p:cNvPr>
+          <p:cNvSpPr>
+            <a:spLocks noGrp="1"/>
+          </p:cNvSpPr>
+          <p:nvPr>
+            <p:ph type="sldNum" sz="quarter" idx="12"/>
+          </p:nvPr>
+        </p:nvSpPr>
+        <p:spPr/>
+        <p:txBody>
+          <a:bodyPr/>
+          <a:lstStyle/>
+          <a:p>
+            <a:fld id="{DF323A44-C1E5-0B49-AAF6-7E9549B7BFD2}" type="slidenum">
+              <a:rPr lang="en-US" smtClean="0"/>
+              <a:t>10</a:t>
+            </a:fld>
+            <a:endParaRPr lang="en-US"/>
           </a:p>
         </p:txBody>
       </p:sp>
@@ -3310,12 +3648,12 @@
   </p:clrMapOvr>
   <mc:AlternateContent xmlns:mc="http://schemas.openxmlformats.org/markup-compatibility/2006" xmlns:p14="http://schemas.microsoft.com/office/powerpoint/2010/main">
     <mc:Choice Requires="p14">
-      <p:transition spd="slow" p14:dur="1200">
-        <p14:prism/>
+      <p:transition spd="slow" p14:dur="2000">
+        <p14:prism isContent="1"/>
       </p:transition>
     </mc:Choice>
     <mc:Fallback xmlns="">
-      <p:transition xmlns:p14="http://schemas.microsoft.com/office/powerpoint/2010/main" spd="slow">
+      <p:transition spd="slow">
         <p:fade/>
       </p:transition>
     </mc:Fallback>
@@ -3358,7 +3696,9 @@
         </p:nvSpPr>
         <p:spPr/>
         <p:txBody>
-          <a:bodyPr/>
+          <a:bodyPr>
+            <a:normAutofit fontScale="90000"/>
+          </a:bodyPr>
           <a:lstStyle/>
           <a:p>
             <a:r>
@@ -3387,7 +3727,7 @@
         <p:spPr/>
         <p:txBody>
           <a:bodyPr>
-            <a:normAutofit fontScale="85000" lnSpcReduction="10000"/>
+            <a:normAutofit fontScale="85000" lnSpcReduction="20000"/>
           </a:bodyPr>
           <a:lstStyle/>
           <a:p>
@@ -3626,6 +3966,92 @@
               <a:latin typeface="Courier New" panose="02070309020205020404" pitchFamily="49" charset="0"/>
               <a:cs typeface="Courier New" panose="02070309020205020404" pitchFamily="49" charset="0"/>
             </a:endParaRPr>
+          </a:p>
+        </p:txBody>
+      </p:sp>
+      <p:sp>
+        <p:nvSpPr>
+          <p:cNvPr id="4" name="Date Placeholder 3">
+            <a:extLst>
+              <a:ext uri="{FF2B5EF4-FFF2-40B4-BE49-F238E27FC236}">
+                <a16:creationId xmlns:a16="http://schemas.microsoft.com/office/drawing/2014/main" id="{EC693A19-4A22-DB8D-ED2B-3F860933F980}"/>
+              </a:ext>
+            </a:extLst>
+          </p:cNvPr>
+          <p:cNvSpPr>
+            <a:spLocks noGrp="1"/>
+          </p:cNvSpPr>
+          <p:nvPr>
+            <p:ph type="dt" sz="half" idx="10"/>
+          </p:nvPr>
+        </p:nvSpPr>
+        <p:spPr/>
+        <p:txBody>
+          <a:bodyPr/>
+          <a:lstStyle/>
+          <a:p>
+            <a:fld id="{9C5B1CA2-2FBF-BF41-9E07-D11DF1CBDA9F}" type="datetime1">
+              <a:rPr lang="en-US" smtClean="0"/>
+              <a:t>10/8/26</a:t>
+            </a:fld>
+            <a:endParaRPr lang="en-US"/>
+          </a:p>
+        </p:txBody>
+      </p:sp>
+      <p:sp>
+        <p:nvSpPr>
+          <p:cNvPr id="5" name="Footer Placeholder 4">
+            <a:extLst>
+              <a:ext uri="{FF2B5EF4-FFF2-40B4-BE49-F238E27FC236}">
+                <a16:creationId xmlns:a16="http://schemas.microsoft.com/office/drawing/2014/main" id="{77C3CAD3-50D9-5A87-0572-28C24D478EB7}"/>
+              </a:ext>
+            </a:extLst>
+          </p:cNvPr>
+          <p:cNvSpPr>
+            <a:spLocks noGrp="1"/>
+          </p:cNvSpPr>
+          <p:nvPr>
+            <p:ph type="ftr" sz="quarter" idx="11"/>
+          </p:nvPr>
+        </p:nvSpPr>
+        <p:spPr/>
+        <p:txBody>
+          <a:bodyPr/>
+          <a:lstStyle/>
+          <a:p>
+            <a:r>
+              <a:rPr lang="en-US"/>
+              <a:t>© Steve Beaty and others as cited</a:t>
+            </a:r>
+          </a:p>
+        </p:txBody>
+      </p:sp>
+      <p:sp>
+        <p:nvSpPr>
+          <p:cNvPr id="6" name="Slide Number Placeholder 5">
+            <a:extLst>
+              <a:ext uri="{FF2B5EF4-FFF2-40B4-BE49-F238E27FC236}">
+                <a16:creationId xmlns:a16="http://schemas.microsoft.com/office/drawing/2014/main" id="{7C6A7CA1-40D2-B5AC-B1F2-89C0CDD3BF98}"/>
+              </a:ext>
+            </a:extLst>
+          </p:cNvPr>
+          <p:cNvSpPr>
+            <a:spLocks noGrp="1"/>
+          </p:cNvSpPr>
+          <p:nvPr>
+            <p:ph type="sldNum" sz="quarter" idx="12"/>
+          </p:nvPr>
+        </p:nvSpPr>
+        <p:spPr/>
+        <p:txBody>
+          <a:bodyPr/>
+          <a:lstStyle/>
+          <a:p>
+            <a:fld id="{DF323A44-C1E5-0B49-AAF6-7E9549B7BFD2}" type="slidenum">
+              <a:rPr lang="en-US" smtClean="0"/>
+              <a:t>11</a:t>
+            </a:fld>
+            <a:endParaRPr lang="en-US"/>
           </a:p>
         </p:txBody>
       </p:sp>
@@ -3689,7 +4115,9 @@
         </p:nvSpPr>
         <p:spPr/>
         <p:txBody>
-          <a:bodyPr/>
+          <a:bodyPr>
+            <a:normAutofit fontScale="90000"/>
+          </a:bodyPr>
           <a:lstStyle/>
           <a:p>
             <a:endParaRPr lang="en-US"/>
@@ -3742,6 +4170,92 @@
               <a:t>UrlHelper.html#method-i-link_to</a:t>
             </a:r>
             <a:endParaRPr lang="en-US" dirty="0"/>
+          </a:p>
+        </p:txBody>
+      </p:sp>
+      <p:sp>
+        <p:nvSpPr>
+          <p:cNvPr id="4" name="Date Placeholder 3">
+            <a:extLst>
+              <a:ext uri="{FF2B5EF4-FFF2-40B4-BE49-F238E27FC236}">
+                <a16:creationId xmlns:a16="http://schemas.microsoft.com/office/drawing/2014/main" id="{7F6E6854-1464-D443-6E58-15A3F51F5C08}"/>
+              </a:ext>
+            </a:extLst>
+          </p:cNvPr>
+          <p:cNvSpPr>
+            <a:spLocks noGrp="1"/>
+          </p:cNvSpPr>
+          <p:nvPr>
+            <p:ph type="dt" sz="half" idx="10"/>
+          </p:nvPr>
+        </p:nvSpPr>
+        <p:spPr/>
+        <p:txBody>
+          <a:bodyPr/>
+          <a:lstStyle/>
+          <a:p>
+            <a:fld id="{A8288872-150D-DA41-BE35-A03612A3EA1B}" type="datetime1">
+              <a:rPr lang="en-US" smtClean="0"/>
+              <a:t>10/8/26</a:t>
+            </a:fld>
+            <a:endParaRPr lang="en-US"/>
+          </a:p>
+        </p:txBody>
+      </p:sp>
+      <p:sp>
+        <p:nvSpPr>
+          <p:cNvPr id="5" name="Footer Placeholder 4">
+            <a:extLst>
+              <a:ext uri="{FF2B5EF4-FFF2-40B4-BE49-F238E27FC236}">
+                <a16:creationId xmlns:a16="http://schemas.microsoft.com/office/drawing/2014/main" id="{ECB8610D-3749-75A4-7B08-E8C79383864C}"/>
+              </a:ext>
+            </a:extLst>
+          </p:cNvPr>
+          <p:cNvSpPr>
+            <a:spLocks noGrp="1"/>
+          </p:cNvSpPr>
+          <p:nvPr>
+            <p:ph type="ftr" sz="quarter" idx="11"/>
+          </p:nvPr>
+        </p:nvSpPr>
+        <p:spPr/>
+        <p:txBody>
+          <a:bodyPr/>
+          <a:lstStyle/>
+          <a:p>
+            <a:r>
+              <a:rPr lang="en-US"/>
+              <a:t>© Steve Beaty and others as cited</a:t>
+            </a:r>
+          </a:p>
+        </p:txBody>
+      </p:sp>
+      <p:sp>
+        <p:nvSpPr>
+          <p:cNvPr id="6" name="Slide Number Placeholder 5">
+            <a:extLst>
+              <a:ext uri="{FF2B5EF4-FFF2-40B4-BE49-F238E27FC236}">
+                <a16:creationId xmlns:a16="http://schemas.microsoft.com/office/drawing/2014/main" id="{242A085C-5433-694F-EB71-BC279BFFD3C9}"/>
+              </a:ext>
+            </a:extLst>
+          </p:cNvPr>
+          <p:cNvSpPr>
+            <a:spLocks noGrp="1"/>
+          </p:cNvSpPr>
+          <p:nvPr>
+            <p:ph type="sldNum" sz="quarter" idx="12"/>
+          </p:nvPr>
+        </p:nvSpPr>
+        <p:spPr/>
+        <p:txBody>
+          <a:bodyPr/>
+          <a:lstStyle/>
+          <a:p>
+            <a:fld id="{DF323A44-C1E5-0B49-AAF6-7E9549B7BFD2}" type="slidenum">
+              <a:rPr lang="en-US" smtClean="0"/>
+              <a:t>12</a:t>
+            </a:fld>
+            <a:endParaRPr lang="en-US"/>
           </a:p>
         </p:txBody>
       </p:sp>
@@ -3757,12 +4271,12 @@
   </p:clrMapOvr>
   <mc:AlternateContent xmlns:mc="http://schemas.openxmlformats.org/markup-compatibility/2006" xmlns:p14="http://schemas.microsoft.com/office/powerpoint/2010/main">
     <mc:Choice Requires="p14">
-      <p:transition spd="slow" p14:dur="1200">
-        <p14:prism/>
+      <p:transition spd="slow" p14:dur="2000">
+        <p14:prism isContent="1"/>
       </p:transition>
     </mc:Choice>
     <mc:Fallback xmlns="">
-      <p:transition xmlns:p14="http://schemas.microsoft.com/office/powerpoint/2010/main" spd="slow">
+      <p:transition spd="slow">
         <p:fade/>
       </p:transition>
     </mc:Fallback>
@@ -3805,7 +4319,9 @@
         </p:nvSpPr>
         <p:spPr/>
         <p:txBody>
-          <a:bodyPr/>
+          <a:bodyPr>
+            <a:normAutofit fontScale="90000"/>
+          </a:bodyPr>
           <a:lstStyle/>
           <a:p>
             <a:r>
@@ -3833,7 +4349,9 @@
         </p:nvSpPr>
         <p:spPr/>
         <p:txBody>
-          <a:bodyPr/>
+          <a:bodyPr>
+            <a:normAutofit lnSpcReduction="10000"/>
+          </a:bodyPr>
           <a:lstStyle/>
           <a:p>
             <a:r>
@@ -3872,6 +4390,92 @@
               </a:rPr>
               <a:t>Take the name of an object to display</a:t>
             </a:r>
+          </a:p>
+        </p:txBody>
+      </p:sp>
+      <p:sp>
+        <p:nvSpPr>
+          <p:cNvPr id="4" name="Date Placeholder 3">
+            <a:extLst>
+              <a:ext uri="{FF2B5EF4-FFF2-40B4-BE49-F238E27FC236}">
+                <a16:creationId xmlns:a16="http://schemas.microsoft.com/office/drawing/2014/main" id="{5E109F8E-ADA5-DA2D-E7AC-AEB75A7E0C62}"/>
+              </a:ext>
+            </a:extLst>
+          </p:cNvPr>
+          <p:cNvSpPr>
+            <a:spLocks noGrp="1"/>
+          </p:cNvSpPr>
+          <p:nvPr>
+            <p:ph type="dt" sz="half" idx="10"/>
+          </p:nvPr>
+        </p:nvSpPr>
+        <p:spPr/>
+        <p:txBody>
+          <a:bodyPr/>
+          <a:lstStyle/>
+          <a:p>
+            <a:fld id="{FC11AABA-87F8-C04D-AFB0-4C4C73800EC5}" type="datetime1">
+              <a:rPr lang="en-US" smtClean="0"/>
+              <a:t>10/8/26</a:t>
+            </a:fld>
+            <a:endParaRPr lang="en-US"/>
+          </a:p>
+        </p:txBody>
+      </p:sp>
+      <p:sp>
+        <p:nvSpPr>
+          <p:cNvPr id="5" name="Footer Placeholder 4">
+            <a:extLst>
+              <a:ext uri="{FF2B5EF4-FFF2-40B4-BE49-F238E27FC236}">
+                <a16:creationId xmlns:a16="http://schemas.microsoft.com/office/drawing/2014/main" id="{DB24E8BA-5D56-64B9-A299-E0624D8C56C9}"/>
+              </a:ext>
+            </a:extLst>
+          </p:cNvPr>
+          <p:cNvSpPr>
+            <a:spLocks noGrp="1"/>
+          </p:cNvSpPr>
+          <p:nvPr>
+            <p:ph type="ftr" sz="quarter" idx="11"/>
+          </p:nvPr>
+        </p:nvSpPr>
+        <p:spPr/>
+        <p:txBody>
+          <a:bodyPr/>
+          <a:lstStyle/>
+          <a:p>
+            <a:r>
+              <a:rPr lang="en-US"/>
+              <a:t>© Steve Beaty and others as cited</a:t>
+            </a:r>
+          </a:p>
+        </p:txBody>
+      </p:sp>
+      <p:sp>
+        <p:nvSpPr>
+          <p:cNvPr id="6" name="Slide Number Placeholder 5">
+            <a:extLst>
+              <a:ext uri="{FF2B5EF4-FFF2-40B4-BE49-F238E27FC236}">
+                <a16:creationId xmlns:a16="http://schemas.microsoft.com/office/drawing/2014/main" id="{EF438F5C-004F-68FC-BB4E-81DE644D115C}"/>
+              </a:ext>
+            </a:extLst>
+          </p:cNvPr>
+          <p:cNvSpPr>
+            <a:spLocks noGrp="1"/>
+          </p:cNvSpPr>
+          <p:nvPr>
+            <p:ph type="sldNum" sz="quarter" idx="12"/>
+          </p:nvPr>
+        </p:nvSpPr>
+        <p:spPr/>
+        <p:txBody>
+          <a:bodyPr/>
+          <a:lstStyle/>
+          <a:p>
+            <a:fld id="{DF323A44-C1E5-0B49-AAF6-7E9549B7BFD2}" type="slidenum">
+              <a:rPr lang="en-US" smtClean="0"/>
+              <a:t>13</a:t>
+            </a:fld>
+            <a:endParaRPr lang="en-US"/>
           </a:p>
         </p:txBody>
       </p:sp>
@@ -3887,12 +4491,12 @@
   </p:clrMapOvr>
   <mc:AlternateContent xmlns:mc="http://schemas.openxmlformats.org/markup-compatibility/2006" xmlns:p14="http://schemas.microsoft.com/office/powerpoint/2010/main">
     <mc:Choice Requires="p14">
-      <p:transition spd="slow" p14:dur="1200">
-        <p14:prism/>
+      <p:transition spd="slow" p14:dur="2000">
+        <p14:prism isContent="1"/>
       </p:transition>
     </mc:Choice>
     <mc:Fallback xmlns="">
-      <p:transition xmlns:p14="http://schemas.microsoft.com/office/powerpoint/2010/main" spd="slow">
+      <p:transition spd="slow">
         <p:fade/>
       </p:transition>
     </mc:Fallback>
@@ -3936,7 +4540,7 @@
         <p:spPr/>
         <p:txBody>
           <a:bodyPr>
-            <a:normAutofit/>
+            <a:normAutofit fontScale="90000"/>
           </a:bodyPr>
           <a:lstStyle/>
           <a:p>
@@ -3971,7 +4575,7 @@
         <p:spPr/>
         <p:txBody>
           <a:bodyPr>
-            <a:normAutofit fontScale="85000" lnSpcReduction="20000"/>
+            <a:normAutofit fontScale="77500" lnSpcReduction="20000"/>
           </a:bodyPr>
           <a:lstStyle/>
           <a:p>
@@ -4704,6 +5308,92 @@
               <a:effectLst/>
               <a:latin typeface="Menlo" panose="020B0609030804020204" pitchFamily="49" charset="0"/>
             </a:endParaRPr>
+          </a:p>
+        </p:txBody>
+      </p:sp>
+      <p:sp>
+        <p:nvSpPr>
+          <p:cNvPr id="4" name="Date Placeholder 3">
+            <a:extLst>
+              <a:ext uri="{FF2B5EF4-FFF2-40B4-BE49-F238E27FC236}">
+                <a16:creationId xmlns:a16="http://schemas.microsoft.com/office/drawing/2014/main" id="{102589F8-DA74-1D17-6056-79CA451C3E10}"/>
+              </a:ext>
+            </a:extLst>
+          </p:cNvPr>
+          <p:cNvSpPr>
+            <a:spLocks noGrp="1"/>
+          </p:cNvSpPr>
+          <p:nvPr>
+            <p:ph type="dt" sz="half" idx="10"/>
+          </p:nvPr>
+        </p:nvSpPr>
+        <p:spPr/>
+        <p:txBody>
+          <a:bodyPr/>
+          <a:lstStyle/>
+          <a:p>
+            <a:fld id="{C20FF26B-50BC-7042-9A11-AF4D15E71BF1}" type="datetime1">
+              <a:rPr lang="en-US" smtClean="0"/>
+              <a:t>10/8/26</a:t>
+            </a:fld>
+            <a:endParaRPr lang="en-US"/>
+          </a:p>
+        </p:txBody>
+      </p:sp>
+      <p:sp>
+        <p:nvSpPr>
+          <p:cNvPr id="5" name="Footer Placeholder 4">
+            <a:extLst>
+              <a:ext uri="{FF2B5EF4-FFF2-40B4-BE49-F238E27FC236}">
+                <a16:creationId xmlns:a16="http://schemas.microsoft.com/office/drawing/2014/main" id="{B4C7680E-2292-4E09-FA51-135F92AAA311}"/>
+              </a:ext>
+            </a:extLst>
+          </p:cNvPr>
+          <p:cNvSpPr>
+            <a:spLocks noGrp="1"/>
+          </p:cNvSpPr>
+          <p:nvPr>
+            <p:ph type="ftr" sz="quarter" idx="11"/>
+          </p:nvPr>
+        </p:nvSpPr>
+        <p:spPr/>
+        <p:txBody>
+          <a:bodyPr/>
+          <a:lstStyle/>
+          <a:p>
+            <a:r>
+              <a:rPr lang="en-US"/>
+              <a:t>© Steve Beaty and others as cited</a:t>
+            </a:r>
+          </a:p>
+        </p:txBody>
+      </p:sp>
+      <p:sp>
+        <p:nvSpPr>
+          <p:cNvPr id="6" name="Slide Number Placeholder 5">
+            <a:extLst>
+              <a:ext uri="{FF2B5EF4-FFF2-40B4-BE49-F238E27FC236}">
+                <a16:creationId xmlns:a16="http://schemas.microsoft.com/office/drawing/2014/main" id="{0E292CED-2CD5-F6F7-E69C-DB1C1E8D3728}"/>
+              </a:ext>
+            </a:extLst>
+          </p:cNvPr>
+          <p:cNvSpPr>
+            <a:spLocks noGrp="1"/>
+          </p:cNvSpPr>
+          <p:nvPr>
+            <p:ph type="sldNum" sz="quarter" idx="12"/>
+          </p:nvPr>
+        </p:nvSpPr>
+        <p:spPr/>
+        <p:txBody>
+          <a:bodyPr/>
+          <a:lstStyle/>
+          <a:p>
+            <a:fld id="{DF323A44-C1E5-0B49-AAF6-7E9549B7BFD2}" type="slidenum">
+              <a:rPr lang="en-US" smtClean="0"/>
+              <a:t>14</a:t>
+            </a:fld>
+            <a:endParaRPr lang="en-US"/>
           </a:p>
         </p:txBody>
       </p:sp>
@@ -4767,7 +5457,9 @@
         </p:nvSpPr>
         <p:spPr/>
         <p:txBody>
-          <a:bodyPr/>
+          <a:bodyPr>
+            <a:normAutofit fontScale="90000"/>
+          </a:bodyPr>
           <a:lstStyle/>
           <a:p>
             <a:r>
@@ -4796,7 +5488,7 @@
         <p:spPr/>
         <p:txBody>
           <a:bodyPr>
-            <a:normAutofit fontScale="70000" lnSpcReduction="20000"/>
+            <a:normAutofit fontScale="62500" lnSpcReduction="20000"/>
           </a:bodyPr>
           <a:lstStyle/>
           <a:p>
@@ -5586,6 +6278,92 @@
               </a:rPr>
               <a:t>&gt;</a:t>
             </a:r>
+          </a:p>
+        </p:txBody>
+      </p:sp>
+      <p:sp>
+        <p:nvSpPr>
+          <p:cNvPr id="4" name="Date Placeholder 3">
+            <a:extLst>
+              <a:ext uri="{FF2B5EF4-FFF2-40B4-BE49-F238E27FC236}">
+                <a16:creationId xmlns:a16="http://schemas.microsoft.com/office/drawing/2014/main" id="{61839FCA-437A-6201-BE7A-0532DD91E6AF}"/>
+              </a:ext>
+            </a:extLst>
+          </p:cNvPr>
+          <p:cNvSpPr>
+            <a:spLocks noGrp="1"/>
+          </p:cNvSpPr>
+          <p:nvPr>
+            <p:ph type="dt" sz="half" idx="10"/>
+          </p:nvPr>
+        </p:nvSpPr>
+        <p:spPr/>
+        <p:txBody>
+          <a:bodyPr/>
+          <a:lstStyle/>
+          <a:p>
+            <a:fld id="{D8E91C48-A5A0-F14F-AF60-5347EF1A101D}" type="datetime1">
+              <a:rPr lang="en-US" smtClean="0"/>
+              <a:t>10/8/26</a:t>
+            </a:fld>
+            <a:endParaRPr lang="en-US"/>
+          </a:p>
+        </p:txBody>
+      </p:sp>
+      <p:sp>
+        <p:nvSpPr>
+          <p:cNvPr id="5" name="Footer Placeholder 4">
+            <a:extLst>
+              <a:ext uri="{FF2B5EF4-FFF2-40B4-BE49-F238E27FC236}">
+                <a16:creationId xmlns:a16="http://schemas.microsoft.com/office/drawing/2014/main" id="{7F81856D-CB27-FDB9-7233-C839B8C8D1CD}"/>
+              </a:ext>
+            </a:extLst>
+          </p:cNvPr>
+          <p:cNvSpPr>
+            <a:spLocks noGrp="1"/>
+          </p:cNvSpPr>
+          <p:nvPr>
+            <p:ph type="ftr" sz="quarter" idx="11"/>
+          </p:nvPr>
+        </p:nvSpPr>
+        <p:spPr/>
+        <p:txBody>
+          <a:bodyPr/>
+          <a:lstStyle/>
+          <a:p>
+            <a:r>
+              <a:rPr lang="en-US"/>
+              <a:t>© Steve Beaty and others as cited</a:t>
+            </a:r>
+          </a:p>
+        </p:txBody>
+      </p:sp>
+      <p:sp>
+        <p:nvSpPr>
+          <p:cNvPr id="6" name="Slide Number Placeholder 5">
+            <a:extLst>
+              <a:ext uri="{FF2B5EF4-FFF2-40B4-BE49-F238E27FC236}">
+                <a16:creationId xmlns:a16="http://schemas.microsoft.com/office/drawing/2014/main" id="{44BE0701-2294-8A82-E471-1312D438260E}"/>
+              </a:ext>
+            </a:extLst>
+          </p:cNvPr>
+          <p:cNvSpPr>
+            <a:spLocks noGrp="1"/>
+          </p:cNvSpPr>
+          <p:nvPr>
+            <p:ph type="sldNum" sz="quarter" idx="12"/>
+          </p:nvPr>
+        </p:nvSpPr>
+        <p:spPr/>
+        <p:txBody>
+          <a:bodyPr/>
+          <a:lstStyle/>
+          <a:p>
+            <a:fld id="{DF323A44-C1E5-0B49-AAF6-7E9549B7BFD2}" type="slidenum">
+              <a:rPr lang="en-US" smtClean="0"/>
+              <a:t>15</a:t>
+            </a:fld>
+            <a:endParaRPr lang="en-US"/>
           </a:p>
         </p:txBody>
       </p:sp>
@@ -5599,6 +6377,18 @@
   <p:clrMapOvr>
     <a:masterClrMapping/>
   </p:clrMapOvr>
+  <mc:AlternateContent xmlns:mc="http://schemas.openxmlformats.org/markup-compatibility/2006" xmlns:p14="http://schemas.microsoft.com/office/powerpoint/2010/main">
+    <mc:Choice Requires="p14">
+      <p:transition spd="slow" p14:dur="2000">
+        <p14:prism isContent="1"/>
+      </p:transition>
+    </mc:Choice>
+    <mc:Fallback xmlns="">
+      <p:transition spd="slow">
+        <p:fade/>
+      </p:transition>
+    </mc:Fallback>
+  </mc:AlternateContent>
 </p:sld>
 </file>
 
@@ -5637,7 +6427,9 @@
         </p:nvSpPr>
         <p:spPr/>
         <p:txBody>
-          <a:bodyPr/>
+          <a:bodyPr>
+            <a:normAutofit fontScale="90000"/>
+          </a:bodyPr>
           <a:lstStyle/>
           <a:p>
             <a:r>
@@ -5678,6 +6470,92 @@
               <a:rPr lang="en-US" dirty="0"/>
               <a:t>We don’t put in explicit strings</a:t>
             </a:r>
+          </a:p>
+        </p:txBody>
+      </p:sp>
+      <p:sp>
+        <p:nvSpPr>
+          <p:cNvPr id="3" name="Date Placeholder 2">
+            <a:extLst>
+              <a:ext uri="{FF2B5EF4-FFF2-40B4-BE49-F238E27FC236}">
+                <a16:creationId xmlns:a16="http://schemas.microsoft.com/office/drawing/2014/main" id="{3FBC1D99-A180-728C-1213-275C10B3C81F}"/>
+              </a:ext>
+            </a:extLst>
+          </p:cNvPr>
+          <p:cNvSpPr>
+            <a:spLocks noGrp="1"/>
+          </p:cNvSpPr>
+          <p:nvPr>
+            <p:ph type="dt" sz="half" idx="10"/>
+          </p:nvPr>
+        </p:nvSpPr>
+        <p:spPr/>
+        <p:txBody>
+          <a:bodyPr/>
+          <a:lstStyle/>
+          <a:p>
+            <a:fld id="{10FA21D9-C020-E346-9E43-E7572D7428E9}" type="datetime1">
+              <a:rPr lang="en-US" smtClean="0"/>
+              <a:t>10/8/26</a:t>
+            </a:fld>
+            <a:endParaRPr lang="en-US"/>
+          </a:p>
+        </p:txBody>
+      </p:sp>
+      <p:sp>
+        <p:nvSpPr>
+          <p:cNvPr id="5" name="Footer Placeholder 4">
+            <a:extLst>
+              <a:ext uri="{FF2B5EF4-FFF2-40B4-BE49-F238E27FC236}">
+                <a16:creationId xmlns:a16="http://schemas.microsoft.com/office/drawing/2014/main" id="{202CDA40-53C9-F3F6-6D14-13932E6C1477}"/>
+              </a:ext>
+            </a:extLst>
+          </p:cNvPr>
+          <p:cNvSpPr>
+            <a:spLocks noGrp="1"/>
+          </p:cNvSpPr>
+          <p:nvPr>
+            <p:ph type="ftr" sz="quarter" idx="11"/>
+          </p:nvPr>
+        </p:nvSpPr>
+        <p:spPr/>
+        <p:txBody>
+          <a:bodyPr/>
+          <a:lstStyle/>
+          <a:p>
+            <a:r>
+              <a:rPr lang="en-US"/>
+              <a:t>© Steve Beaty and others as cited</a:t>
+            </a:r>
+          </a:p>
+        </p:txBody>
+      </p:sp>
+      <p:sp>
+        <p:nvSpPr>
+          <p:cNvPr id="6" name="Slide Number Placeholder 5">
+            <a:extLst>
+              <a:ext uri="{FF2B5EF4-FFF2-40B4-BE49-F238E27FC236}">
+                <a16:creationId xmlns:a16="http://schemas.microsoft.com/office/drawing/2014/main" id="{7B3A1308-1AE8-E4E6-C7FD-6308271D98E4}"/>
+              </a:ext>
+            </a:extLst>
+          </p:cNvPr>
+          <p:cNvSpPr>
+            <a:spLocks noGrp="1"/>
+          </p:cNvSpPr>
+          <p:nvPr>
+            <p:ph type="sldNum" sz="quarter" idx="12"/>
+          </p:nvPr>
+        </p:nvSpPr>
+        <p:spPr/>
+        <p:txBody>
+          <a:bodyPr/>
+          <a:lstStyle/>
+          <a:p>
+            <a:fld id="{DF323A44-C1E5-0B49-AAF6-7E9549B7BFD2}" type="slidenum">
+              <a:rPr lang="en-US" smtClean="0"/>
+              <a:t>16</a:t>
+            </a:fld>
+            <a:endParaRPr lang="en-US"/>
           </a:p>
         </p:txBody>
       </p:sp>
@@ -5693,12 +6571,12 @@
   </p:clrMapOvr>
   <mc:AlternateContent xmlns:mc="http://schemas.openxmlformats.org/markup-compatibility/2006" xmlns:p14="http://schemas.microsoft.com/office/powerpoint/2010/main">
     <mc:Choice Requires="p14">
-      <p:transition spd="slow" p14:dur="1200">
-        <p14:prism/>
+      <p:transition spd="slow" p14:dur="2000">
+        <p14:prism isContent="1"/>
       </p:transition>
     </mc:Choice>
     <mc:Fallback xmlns="">
-      <p:transition xmlns:p14="http://schemas.microsoft.com/office/powerpoint/2010/main" spd="slow">
+      <p:transition spd="slow">
         <p:fade/>
       </p:transition>
     </mc:Fallback>
@@ -5741,7 +6619,9 @@
         </p:nvSpPr>
         <p:spPr/>
         <p:txBody>
-          <a:bodyPr/>
+          <a:bodyPr>
+            <a:normAutofit fontScale="90000"/>
+          </a:bodyPr>
           <a:lstStyle/>
           <a:p>
             <a:r>
@@ -5769,7 +6649,9 @@
         </p:nvSpPr>
         <p:spPr/>
         <p:txBody>
-          <a:bodyPr/>
+          <a:bodyPr>
+            <a:normAutofit lnSpcReduction="10000"/>
+          </a:bodyPr>
           <a:lstStyle/>
           <a:p>
             <a:r>
@@ -5829,6 +6711,92 @@
               </a:rPr>
               <a:t>t and l aliases</a:t>
             </a:r>
+          </a:p>
+        </p:txBody>
+      </p:sp>
+      <p:sp>
+        <p:nvSpPr>
+          <p:cNvPr id="4" name="Date Placeholder 3">
+            <a:extLst>
+              <a:ext uri="{FF2B5EF4-FFF2-40B4-BE49-F238E27FC236}">
+                <a16:creationId xmlns:a16="http://schemas.microsoft.com/office/drawing/2014/main" id="{ECC2B7D7-3D1A-3296-DF01-7D376C43CBBA}"/>
+              </a:ext>
+            </a:extLst>
+          </p:cNvPr>
+          <p:cNvSpPr>
+            <a:spLocks noGrp="1"/>
+          </p:cNvSpPr>
+          <p:nvPr>
+            <p:ph type="dt" sz="half" idx="10"/>
+          </p:nvPr>
+        </p:nvSpPr>
+        <p:spPr/>
+        <p:txBody>
+          <a:bodyPr/>
+          <a:lstStyle/>
+          <a:p>
+            <a:fld id="{4569B024-49CD-E84B-9E97-9349959EB1F0}" type="datetime1">
+              <a:rPr lang="en-US" smtClean="0"/>
+              <a:t>10/8/26</a:t>
+            </a:fld>
+            <a:endParaRPr lang="en-US"/>
+          </a:p>
+        </p:txBody>
+      </p:sp>
+      <p:sp>
+        <p:nvSpPr>
+          <p:cNvPr id="5" name="Footer Placeholder 4">
+            <a:extLst>
+              <a:ext uri="{FF2B5EF4-FFF2-40B4-BE49-F238E27FC236}">
+                <a16:creationId xmlns:a16="http://schemas.microsoft.com/office/drawing/2014/main" id="{BBCEEDC6-5337-B45F-4F3C-B1ECF49016B2}"/>
+              </a:ext>
+            </a:extLst>
+          </p:cNvPr>
+          <p:cNvSpPr>
+            <a:spLocks noGrp="1"/>
+          </p:cNvSpPr>
+          <p:nvPr>
+            <p:ph type="ftr" sz="quarter" idx="11"/>
+          </p:nvPr>
+        </p:nvSpPr>
+        <p:spPr/>
+        <p:txBody>
+          <a:bodyPr/>
+          <a:lstStyle/>
+          <a:p>
+            <a:r>
+              <a:rPr lang="en-US"/>
+              <a:t>© Steve Beaty and others as cited</a:t>
+            </a:r>
+          </a:p>
+        </p:txBody>
+      </p:sp>
+      <p:sp>
+        <p:nvSpPr>
+          <p:cNvPr id="6" name="Slide Number Placeholder 5">
+            <a:extLst>
+              <a:ext uri="{FF2B5EF4-FFF2-40B4-BE49-F238E27FC236}">
+                <a16:creationId xmlns:a16="http://schemas.microsoft.com/office/drawing/2014/main" id="{1538BD54-35CB-4BD5-9E32-C22C632B3CF6}"/>
+              </a:ext>
+            </a:extLst>
+          </p:cNvPr>
+          <p:cNvSpPr>
+            <a:spLocks noGrp="1"/>
+          </p:cNvSpPr>
+          <p:nvPr>
+            <p:ph type="sldNum" sz="quarter" idx="12"/>
+          </p:nvPr>
+        </p:nvSpPr>
+        <p:spPr/>
+        <p:txBody>
+          <a:bodyPr/>
+          <a:lstStyle/>
+          <a:p>
+            <a:fld id="{DF323A44-C1E5-0B49-AAF6-7E9549B7BFD2}" type="slidenum">
+              <a:rPr lang="en-US" smtClean="0"/>
+              <a:t>17</a:t>
+            </a:fld>
+            <a:endParaRPr lang="en-US"/>
           </a:p>
         </p:txBody>
       </p:sp>
@@ -5844,12 +6812,12 @@
   </p:clrMapOvr>
   <mc:AlternateContent xmlns:mc="http://schemas.openxmlformats.org/markup-compatibility/2006" xmlns:p14="http://schemas.microsoft.com/office/powerpoint/2010/main">
     <mc:Choice Requires="p14">
-      <p:transition spd="slow" p14:dur="1200">
-        <p14:prism/>
+      <p:transition spd="slow" p14:dur="2000">
+        <p14:prism isContent="1"/>
       </p:transition>
     </mc:Choice>
     <mc:Fallback xmlns="">
-      <p:transition xmlns:p14="http://schemas.microsoft.com/office/powerpoint/2010/main" spd="slow">
+      <p:transition spd="slow">
         <p:fade/>
       </p:transition>
     </mc:Fallback>
@@ -5892,7 +6860,9 @@
         </p:nvSpPr>
         <p:spPr/>
         <p:txBody>
-          <a:bodyPr/>
+          <a:bodyPr>
+            <a:normAutofit fontScale="90000"/>
+          </a:bodyPr>
           <a:lstStyle/>
           <a:p>
             <a:r>
@@ -5979,6 +6949,92 @@
           </a:p>
           <a:p>
             <a:endParaRPr lang="en-US" dirty="0"/>
+          </a:p>
+        </p:txBody>
+      </p:sp>
+      <p:sp>
+        <p:nvSpPr>
+          <p:cNvPr id="4" name="Date Placeholder 3">
+            <a:extLst>
+              <a:ext uri="{FF2B5EF4-FFF2-40B4-BE49-F238E27FC236}">
+                <a16:creationId xmlns:a16="http://schemas.microsoft.com/office/drawing/2014/main" id="{9FA39164-2184-3BC7-7744-F8D12D18A39E}"/>
+              </a:ext>
+            </a:extLst>
+          </p:cNvPr>
+          <p:cNvSpPr>
+            <a:spLocks noGrp="1"/>
+          </p:cNvSpPr>
+          <p:nvPr>
+            <p:ph type="dt" sz="half" idx="10"/>
+          </p:nvPr>
+        </p:nvSpPr>
+        <p:spPr/>
+        <p:txBody>
+          <a:bodyPr/>
+          <a:lstStyle/>
+          <a:p>
+            <a:fld id="{3EA9CAA6-1EB0-A14A-B584-1FD091AECF07}" type="datetime1">
+              <a:rPr lang="en-US" smtClean="0"/>
+              <a:t>10/8/26</a:t>
+            </a:fld>
+            <a:endParaRPr lang="en-US"/>
+          </a:p>
+        </p:txBody>
+      </p:sp>
+      <p:sp>
+        <p:nvSpPr>
+          <p:cNvPr id="5" name="Footer Placeholder 4">
+            <a:extLst>
+              <a:ext uri="{FF2B5EF4-FFF2-40B4-BE49-F238E27FC236}">
+                <a16:creationId xmlns:a16="http://schemas.microsoft.com/office/drawing/2014/main" id="{05F8F661-7720-6E2B-3033-C21CE543C1A0}"/>
+              </a:ext>
+            </a:extLst>
+          </p:cNvPr>
+          <p:cNvSpPr>
+            <a:spLocks noGrp="1"/>
+          </p:cNvSpPr>
+          <p:nvPr>
+            <p:ph type="ftr" sz="quarter" idx="11"/>
+          </p:nvPr>
+        </p:nvSpPr>
+        <p:spPr/>
+        <p:txBody>
+          <a:bodyPr/>
+          <a:lstStyle/>
+          <a:p>
+            <a:r>
+              <a:rPr lang="en-US"/>
+              <a:t>© Steve Beaty and others as cited</a:t>
+            </a:r>
+          </a:p>
+        </p:txBody>
+      </p:sp>
+      <p:sp>
+        <p:nvSpPr>
+          <p:cNvPr id="6" name="Slide Number Placeholder 5">
+            <a:extLst>
+              <a:ext uri="{FF2B5EF4-FFF2-40B4-BE49-F238E27FC236}">
+                <a16:creationId xmlns:a16="http://schemas.microsoft.com/office/drawing/2014/main" id="{FB901C39-BF42-5629-4F4E-73661A25C8B3}"/>
+              </a:ext>
+            </a:extLst>
+          </p:cNvPr>
+          <p:cNvSpPr>
+            <a:spLocks noGrp="1"/>
+          </p:cNvSpPr>
+          <p:nvPr>
+            <p:ph type="sldNum" sz="quarter" idx="12"/>
+          </p:nvPr>
+        </p:nvSpPr>
+        <p:spPr/>
+        <p:txBody>
+          <a:bodyPr/>
+          <a:lstStyle/>
+          <a:p>
+            <a:fld id="{DF323A44-C1E5-0B49-AAF6-7E9549B7BFD2}" type="slidenum">
+              <a:rPr lang="en-US" smtClean="0"/>
+              <a:t>18</a:t>
+            </a:fld>
+            <a:endParaRPr lang="en-US"/>
           </a:p>
         </p:txBody>
       </p:sp>
@@ -6042,7 +7098,9 @@
         </p:nvSpPr>
         <p:spPr/>
         <p:txBody>
-          <a:bodyPr/>
+          <a:bodyPr>
+            <a:normAutofit fontScale="90000"/>
+          </a:bodyPr>
           <a:lstStyle/>
           <a:p>
             <a:r>
@@ -6071,7 +7129,7 @@
         <p:spPr/>
         <p:txBody>
           <a:bodyPr>
-            <a:normAutofit fontScale="47500" lnSpcReduction="20000"/>
+            <a:normAutofit fontScale="40000" lnSpcReduction="20000"/>
           </a:bodyPr>
           <a:lstStyle/>
           <a:p>
@@ -7400,6 +8458,92 @@
               <a:effectLst/>
               <a:latin typeface="Menlo" panose="020B0609030804020204" pitchFamily="49" charset="0"/>
             </a:endParaRPr>
+          </a:p>
+        </p:txBody>
+      </p:sp>
+      <p:sp>
+        <p:nvSpPr>
+          <p:cNvPr id="4" name="Date Placeholder 3">
+            <a:extLst>
+              <a:ext uri="{FF2B5EF4-FFF2-40B4-BE49-F238E27FC236}">
+                <a16:creationId xmlns:a16="http://schemas.microsoft.com/office/drawing/2014/main" id="{B6618FE8-8530-6DA4-DADC-857D8FBB4E10}"/>
+              </a:ext>
+            </a:extLst>
+          </p:cNvPr>
+          <p:cNvSpPr>
+            <a:spLocks noGrp="1"/>
+          </p:cNvSpPr>
+          <p:nvPr>
+            <p:ph type="dt" sz="half" idx="10"/>
+          </p:nvPr>
+        </p:nvSpPr>
+        <p:spPr/>
+        <p:txBody>
+          <a:bodyPr/>
+          <a:lstStyle/>
+          <a:p>
+            <a:fld id="{0576ADC0-5EE2-E24B-892E-2727936368B0}" type="datetime1">
+              <a:rPr lang="en-US" smtClean="0"/>
+              <a:t>10/8/26</a:t>
+            </a:fld>
+            <a:endParaRPr lang="en-US"/>
+          </a:p>
+        </p:txBody>
+      </p:sp>
+      <p:sp>
+        <p:nvSpPr>
+          <p:cNvPr id="5" name="Footer Placeholder 4">
+            <a:extLst>
+              <a:ext uri="{FF2B5EF4-FFF2-40B4-BE49-F238E27FC236}">
+                <a16:creationId xmlns:a16="http://schemas.microsoft.com/office/drawing/2014/main" id="{9A0F05EA-5EF6-7247-A118-5462870C11F6}"/>
+              </a:ext>
+            </a:extLst>
+          </p:cNvPr>
+          <p:cNvSpPr>
+            <a:spLocks noGrp="1"/>
+          </p:cNvSpPr>
+          <p:nvPr>
+            <p:ph type="ftr" sz="quarter" idx="11"/>
+          </p:nvPr>
+        </p:nvSpPr>
+        <p:spPr/>
+        <p:txBody>
+          <a:bodyPr/>
+          <a:lstStyle/>
+          <a:p>
+            <a:r>
+              <a:rPr lang="en-US"/>
+              <a:t>© Steve Beaty and others as cited</a:t>
+            </a:r>
+          </a:p>
+        </p:txBody>
+      </p:sp>
+      <p:sp>
+        <p:nvSpPr>
+          <p:cNvPr id="6" name="Slide Number Placeholder 5">
+            <a:extLst>
+              <a:ext uri="{FF2B5EF4-FFF2-40B4-BE49-F238E27FC236}">
+                <a16:creationId xmlns:a16="http://schemas.microsoft.com/office/drawing/2014/main" id="{B15E8544-6251-5522-F369-1669BAA02666}"/>
+              </a:ext>
+            </a:extLst>
+          </p:cNvPr>
+          <p:cNvSpPr>
+            <a:spLocks noGrp="1"/>
+          </p:cNvSpPr>
+          <p:nvPr>
+            <p:ph type="sldNum" sz="quarter" idx="12"/>
+          </p:nvPr>
+        </p:nvSpPr>
+        <p:spPr/>
+        <p:txBody>
+          <a:bodyPr/>
+          <a:lstStyle/>
+          <a:p>
+            <a:fld id="{DF323A44-C1E5-0B49-AAF6-7E9549B7BFD2}" type="slidenum">
+              <a:rPr lang="en-US" smtClean="0"/>
+              <a:t>19</a:t>
+            </a:fld>
+            <a:endParaRPr lang="en-US"/>
           </a:p>
         </p:txBody>
       </p:sp>
@@ -7413,6 +8557,18 @@
   <p:clrMapOvr>
     <a:masterClrMapping/>
   </p:clrMapOvr>
+  <mc:AlternateContent xmlns:mc="http://schemas.openxmlformats.org/markup-compatibility/2006" xmlns:p14="http://schemas.microsoft.com/office/powerpoint/2010/main">
+    <mc:Choice Requires="p14">
+      <p:transition spd="slow" p14:dur="2000">
+        <p14:prism isContent="1"/>
+      </p:transition>
+    </mc:Choice>
+    <mc:Fallback xmlns="">
+      <p:transition spd="slow">
+        <p:fade/>
+      </p:transition>
+    </mc:Fallback>
+  </mc:AlternateContent>
 </p:sld>
 </file>
 
@@ -7451,7 +8607,9 @@
         </p:nvSpPr>
         <p:spPr/>
         <p:txBody>
-          <a:bodyPr/>
+          <a:bodyPr>
+            <a:normAutofit fontScale="90000"/>
+          </a:bodyPr>
           <a:lstStyle/>
           <a:p>
             <a:r>
@@ -7495,6 +8653,92 @@
           </a:p>
           <a:p>
             <a:endParaRPr lang="en-US" dirty="0"/>
+          </a:p>
+        </p:txBody>
+      </p:sp>
+      <p:sp>
+        <p:nvSpPr>
+          <p:cNvPr id="4" name="Date Placeholder 3">
+            <a:extLst>
+              <a:ext uri="{FF2B5EF4-FFF2-40B4-BE49-F238E27FC236}">
+                <a16:creationId xmlns:a16="http://schemas.microsoft.com/office/drawing/2014/main" id="{4C337E4C-4B6A-40AF-EFEC-8B7B0617AD7C}"/>
+              </a:ext>
+            </a:extLst>
+          </p:cNvPr>
+          <p:cNvSpPr>
+            <a:spLocks noGrp="1"/>
+          </p:cNvSpPr>
+          <p:nvPr>
+            <p:ph type="dt" sz="half" idx="10"/>
+          </p:nvPr>
+        </p:nvSpPr>
+        <p:spPr/>
+        <p:txBody>
+          <a:bodyPr/>
+          <a:lstStyle/>
+          <a:p>
+            <a:fld id="{E5CDDDAC-68F1-7C48-AA0D-61A5609E6F31}" type="datetime1">
+              <a:rPr lang="en-US" smtClean="0"/>
+              <a:t>10/8/26</a:t>
+            </a:fld>
+            <a:endParaRPr lang="en-US"/>
+          </a:p>
+        </p:txBody>
+      </p:sp>
+      <p:sp>
+        <p:nvSpPr>
+          <p:cNvPr id="5" name="Footer Placeholder 4">
+            <a:extLst>
+              <a:ext uri="{FF2B5EF4-FFF2-40B4-BE49-F238E27FC236}">
+                <a16:creationId xmlns:a16="http://schemas.microsoft.com/office/drawing/2014/main" id="{EED05846-0084-42BA-62B0-D82786731D6D}"/>
+              </a:ext>
+            </a:extLst>
+          </p:cNvPr>
+          <p:cNvSpPr>
+            <a:spLocks noGrp="1"/>
+          </p:cNvSpPr>
+          <p:nvPr>
+            <p:ph type="ftr" sz="quarter" idx="11"/>
+          </p:nvPr>
+        </p:nvSpPr>
+        <p:spPr/>
+        <p:txBody>
+          <a:bodyPr/>
+          <a:lstStyle/>
+          <a:p>
+            <a:r>
+              <a:rPr lang="en-US"/>
+              <a:t>© Steve Beaty and others as cited</a:t>
+            </a:r>
+          </a:p>
+        </p:txBody>
+      </p:sp>
+      <p:sp>
+        <p:nvSpPr>
+          <p:cNvPr id="6" name="Slide Number Placeholder 5">
+            <a:extLst>
+              <a:ext uri="{FF2B5EF4-FFF2-40B4-BE49-F238E27FC236}">
+                <a16:creationId xmlns:a16="http://schemas.microsoft.com/office/drawing/2014/main" id="{34E2F95D-44DF-F812-87E4-F2D81061B8AC}"/>
+              </a:ext>
+            </a:extLst>
+          </p:cNvPr>
+          <p:cNvSpPr>
+            <a:spLocks noGrp="1"/>
+          </p:cNvSpPr>
+          <p:nvPr>
+            <p:ph type="sldNum" sz="quarter" idx="12"/>
+          </p:nvPr>
+        </p:nvSpPr>
+        <p:spPr/>
+        <p:txBody>
+          <a:bodyPr/>
+          <a:lstStyle/>
+          <a:p>
+            <a:fld id="{DF323A44-C1E5-0B49-AAF6-7E9549B7BFD2}" type="slidenum">
+              <a:rPr lang="en-US" smtClean="0"/>
+              <a:t>2</a:t>
+            </a:fld>
+            <a:endParaRPr lang="en-US"/>
           </a:p>
         </p:txBody>
       </p:sp>
@@ -7510,12 +8754,12 @@
   </p:clrMapOvr>
   <mc:AlternateContent xmlns:mc="http://schemas.openxmlformats.org/markup-compatibility/2006" xmlns:p14="http://schemas.microsoft.com/office/powerpoint/2010/main">
     <mc:Choice Requires="p14">
-      <p:transition spd="slow" p14:dur="1200">
-        <p14:prism/>
+      <p:transition spd="slow" p14:dur="2000">
+        <p14:prism isContent="1"/>
       </p:transition>
     </mc:Choice>
     <mc:Fallback xmlns="">
-      <p:transition xmlns:p14="http://schemas.microsoft.com/office/powerpoint/2010/main" spd="slow">
+      <p:transition spd="slow">
         <p:fade/>
       </p:transition>
     </mc:Fallback>
@@ -7558,7 +8802,9 @@
         </p:nvSpPr>
         <p:spPr/>
         <p:txBody>
-          <a:bodyPr/>
+          <a:bodyPr>
+            <a:normAutofit fontScale="90000"/>
+          </a:bodyPr>
           <a:lstStyle/>
           <a:p>
             <a:r>
@@ -7599,6 +8845,92 @@
               <a:rPr lang="en-US" dirty="0"/>
               <a:t>Trix is essentially built in</a:t>
             </a:r>
+          </a:p>
+        </p:txBody>
+      </p:sp>
+      <p:sp>
+        <p:nvSpPr>
+          <p:cNvPr id="3" name="Date Placeholder 2">
+            <a:extLst>
+              <a:ext uri="{FF2B5EF4-FFF2-40B4-BE49-F238E27FC236}">
+                <a16:creationId xmlns:a16="http://schemas.microsoft.com/office/drawing/2014/main" id="{6C06EE6B-61DB-4FA1-B848-E6572886928F}"/>
+              </a:ext>
+            </a:extLst>
+          </p:cNvPr>
+          <p:cNvSpPr>
+            <a:spLocks noGrp="1"/>
+          </p:cNvSpPr>
+          <p:nvPr>
+            <p:ph type="dt" sz="half" idx="10"/>
+          </p:nvPr>
+        </p:nvSpPr>
+        <p:spPr/>
+        <p:txBody>
+          <a:bodyPr/>
+          <a:lstStyle/>
+          <a:p>
+            <a:fld id="{6576F1E2-559E-CD40-8FDD-BC65FD519493}" type="datetime1">
+              <a:rPr lang="en-US" smtClean="0"/>
+              <a:t>10/8/26</a:t>
+            </a:fld>
+            <a:endParaRPr lang="en-US"/>
+          </a:p>
+        </p:txBody>
+      </p:sp>
+      <p:sp>
+        <p:nvSpPr>
+          <p:cNvPr id="5" name="Footer Placeholder 4">
+            <a:extLst>
+              <a:ext uri="{FF2B5EF4-FFF2-40B4-BE49-F238E27FC236}">
+                <a16:creationId xmlns:a16="http://schemas.microsoft.com/office/drawing/2014/main" id="{14FC2AEF-4D55-9A24-FF98-3CEC08B54D87}"/>
+              </a:ext>
+            </a:extLst>
+          </p:cNvPr>
+          <p:cNvSpPr>
+            <a:spLocks noGrp="1"/>
+          </p:cNvSpPr>
+          <p:nvPr>
+            <p:ph type="ftr" sz="quarter" idx="11"/>
+          </p:nvPr>
+        </p:nvSpPr>
+        <p:spPr/>
+        <p:txBody>
+          <a:bodyPr/>
+          <a:lstStyle/>
+          <a:p>
+            <a:r>
+              <a:rPr lang="en-US"/>
+              <a:t>© Steve Beaty and others as cited</a:t>
+            </a:r>
+          </a:p>
+        </p:txBody>
+      </p:sp>
+      <p:sp>
+        <p:nvSpPr>
+          <p:cNvPr id="6" name="Slide Number Placeholder 5">
+            <a:extLst>
+              <a:ext uri="{FF2B5EF4-FFF2-40B4-BE49-F238E27FC236}">
+                <a16:creationId xmlns:a16="http://schemas.microsoft.com/office/drawing/2014/main" id="{C48C02C8-844E-61C6-F987-B52C773D21FA}"/>
+              </a:ext>
+            </a:extLst>
+          </p:cNvPr>
+          <p:cNvSpPr>
+            <a:spLocks noGrp="1"/>
+          </p:cNvSpPr>
+          <p:nvPr>
+            <p:ph type="sldNum" sz="quarter" idx="12"/>
+          </p:nvPr>
+        </p:nvSpPr>
+        <p:spPr/>
+        <p:txBody>
+          <a:bodyPr/>
+          <a:lstStyle/>
+          <a:p>
+            <a:fld id="{DF323A44-C1E5-0B49-AAF6-7E9549B7BFD2}" type="slidenum">
+              <a:rPr lang="en-US" smtClean="0"/>
+              <a:t>20</a:t>
+            </a:fld>
+            <a:endParaRPr lang="en-US"/>
           </a:p>
         </p:txBody>
       </p:sp>
@@ -7614,12 +8946,12 @@
   </p:clrMapOvr>
   <mc:AlternateContent xmlns:mc="http://schemas.openxmlformats.org/markup-compatibility/2006" xmlns:p14="http://schemas.microsoft.com/office/powerpoint/2010/main">
     <mc:Choice Requires="p14">
-      <p:transition spd="slow" p14:dur="1200">
-        <p14:prism/>
+      <p:transition spd="slow" p14:dur="2000">
+        <p14:prism isContent="1"/>
       </p:transition>
     </mc:Choice>
     <mc:Fallback xmlns="">
-      <p:transition xmlns:p14="http://schemas.microsoft.com/office/powerpoint/2010/main" spd="slow">
+      <p:transition spd="slow">
         <p:fade/>
       </p:transition>
     </mc:Fallback>
@@ -7662,7 +8994,9 @@
         </p:nvSpPr>
         <p:spPr/>
         <p:txBody>
-          <a:bodyPr/>
+          <a:bodyPr>
+            <a:normAutofit fontScale="90000"/>
+          </a:bodyPr>
           <a:lstStyle/>
           <a:p>
             <a:r>
@@ -7748,6 +9082,92 @@
               <a:t>db:migrate</a:t>
             </a:r>
             <a:endParaRPr lang="en-US" sz="2400" dirty="0"/>
+          </a:p>
+        </p:txBody>
+      </p:sp>
+      <p:sp>
+        <p:nvSpPr>
+          <p:cNvPr id="3" name="Date Placeholder 2">
+            <a:extLst>
+              <a:ext uri="{FF2B5EF4-FFF2-40B4-BE49-F238E27FC236}">
+                <a16:creationId xmlns:a16="http://schemas.microsoft.com/office/drawing/2014/main" id="{14D43FAB-43EF-5AB3-31A7-CA74307DE7DD}"/>
+              </a:ext>
+            </a:extLst>
+          </p:cNvPr>
+          <p:cNvSpPr>
+            <a:spLocks noGrp="1"/>
+          </p:cNvSpPr>
+          <p:nvPr>
+            <p:ph type="dt" sz="half" idx="10"/>
+          </p:nvPr>
+        </p:nvSpPr>
+        <p:spPr/>
+        <p:txBody>
+          <a:bodyPr/>
+          <a:lstStyle/>
+          <a:p>
+            <a:fld id="{44DC0705-4495-8D4A-8E55-F91F7F0B9562}" type="datetime1">
+              <a:rPr lang="en-US" smtClean="0"/>
+              <a:t>10/8/26</a:t>
+            </a:fld>
+            <a:endParaRPr lang="en-US"/>
+          </a:p>
+        </p:txBody>
+      </p:sp>
+      <p:sp>
+        <p:nvSpPr>
+          <p:cNvPr id="5" name="Footer Placeholder 4">
+            <a:extLst>
+              <a:ext uri="{FF2B5EF4-FFF2-40B4-BE49-F238E27FC236}">
+                <a16:creationId xmlns:a16="http://schemas.microsoft.com/office/drawing/2014/main" id="{2CCED21B-437A-7D8C-D49B-0EAB6AC998B1}"/>
+              </a:ext>
+            </a:extLst>
+          </p:cNvPr>
+          <p:cNvSpPr>
+            <a:spLocks noGrp="1"/>
+          </p:cNvSpPr>
+          <p:nvPr>
+            <p:ph type="ftr" sz="quarter" idx="11"/>
+          </p:nvPr>
+        </p:nvSpPr>
+        <p:spPr/>
+        <p:txBody>
+          <a:bodyPr/>
+          <a:lstStyle/>
+          <a:p>
+            <a:r>
+              <a:rPr lang="en-US"/>
+              <a:t>© Steve Beaty and others as cited</a:t>
+            </a:r>
+          </a:p>
+        </p:txBody>
+      </p:sp>
+      <p:sp>
+        <p:nvSpPr>
+          <p:cNvPr id="6" name="Slide Number Placeholder 5">
+            <a:extLst>
+              <a:ext uri="{FF2B5EF4-FFF2-40B4-BE49-F238E27FC236}">
+                <a16:creationId xmlns:a16="http://schemas.microsoft.com/office/drawing/2014/main" id="{5E97EF48-E94F-D52B-224A-1E04D2426A80}"/>
+              </a:ext>
+            </a:extLst>
+          </p:cNvPr>
+          <p:cNvSpPr>
+            <a:spLocks noGrp="1"/>
+          </p:cNvSpPr>
+          <p:nvPr>
+            <p:ph type="sldNum" sz="quarter" idx="12"/>
+          </p:nvPr>
+        </p:nvSpPr>
+        <p:spPr/>
+        <p:txBody>
+          <a:bodyPr/>
+          <a:lstStyle/>
+          <a:p>
+            <a:fld id="{DF323A44-C1E5-0B49-AAF6-7E9549B7BFD2}" type="slidenum">
+              <a:rPr lang="en-US" smtClean="0"/>
+              <a:t>21</a:t>
+            </a:fld>
+            <a:endParaRPr lang="en-US"/>
           </a:p>
         </p:txBody>
       </p:sp>
@@ -7811,7 +9231,9 @@
         </p:nvSpPr>
         <p:spPr/>
         <p:txBody>
-          <a:bodyPr/>
+          <a:bodyPr>
+            <a:normAutofit fontScale="90000"/>
+          </a:bodyPr>
           <a:lstStyle/>
           <a:p>
             <a:r>
@@ -7839,7 +9261,9 @@
         </p:nvSpPr>
         <p:spPr/>
         <p:txBody>
-          <a:bodyPr/>
+          <a:bodyPr>
+            <a:normAutofit lnSpcReduction="10000"/>
+          </a:bodyPr>
           <a:lstStyle/>
           <a:p>
             <a:r>
@@ -7880,6 +9304,92 @@
               <a:rPr lang="en-US" dirty="0"/>
               <a:t>DRY</a:t>
             </a:r>
+          </a:p>
+        </p:txBody>
+      </p:sp>
+      <p:sp>
+        <p:nvSpPr>
+          <p:cNvPr id="3" name="Date Placeholder 2">
+            <a:extLst>
+              <a:ext uri="{FF2B5EF4-FFF2-40B4-BE49-F238E27FC236}">
+                <a16:creationId xmlns:a16="http://schemas.microsoft.com/office/drawing/2014/main" id="{15CC35C3-575D-E740-F6A0-7237EE5DAC83}"/>
+              </a:ext>
+            </a:extLst>
+          </p:cNvPr>
+          <p:cNvSpPr>
+            <a:spLocks noGrp="1"/>
+          </p:cNvSpPr>
+          <p:nvPr>
+            <p:ph type="dt" sz="half" idx="10"/>
+          </p:nvPr>
+        </p:nvSpPr>
+        <p:spPr/>
+        <p:txBody>
+          <a:bodyPr/>
+          <a:lstStyle/>
+          <a:p>
+            <a:fld id="{C365FA16-E373-094F-836C-8CF74F19E0EA}" type="datetime1">
+              <a:rPr lang="en-US" smtClean="0"/>
+              <a:t>10/8/26</a:t>
+            </a:fld>
+            <a:endParaRPr lang="en-US"/>
+          </a:p>
+        </p:txBody>
+      </p:sp>
+      <p:sp>
+        <p:nvSpPr>
+          <p:cNvPr id="5" name="Footer Placeholder 4">
+            <a:extLst>
+              <a:ext uri="{FF2B5EF4-FFF2-40B4-BE49-F238E27FC236}">
+                <a16:creationId xmlns:a16="http://schemas.microsoft.com/office/drawing/2014/main" id="{5E3FFF81-D2FA-C999-D3E5-D8606ECE141D}"/>
+              </a:ext>
+            </a:extLst>
+          </p:cNvPr>
+          <p:cNvSpPr>
+            <a:spLocks noGrp="1"/>
+          </p:cNvSpPr>
+          <p:nvPr>
+            <p:ph type="ftr" sz="quarter" idx="11"/>
+          </p:nvPr>
+        </p:nvSpPr>
+        <p:spPr/>
+        <p:txBody>
+          <a:bodyPr/>
+          <a:lstStyle/>
+          <a:p>
+            <a:r>
+              <a:rPr lang="en-US"/>
+              <a:t>© Steve Beaty and others as cited</a:t>
+            </a:r>
+          </a:p>
+        </p:txBody>
+      </p:sp>
+      <p:sp>
+        <p:nvSpPr>
+          <p:cNvPr id="6" name="Slide Number Placeholder 5">
+            <a:extLst>
+              <a:ext uri="{FF2B5EF4-FFF2-40B4-BE49-F238E27FC236}">
+                <a16:creationId xmlns:a16="http://schemas.microsoft.com/office/drawing/2014/main" id="{ACC45B6C-AD4C-4F05-0224-23D08897FCAA}"/>
+              </a:ext>
+            </a:extLst>
+          </p:cNvPr>
+          <p:cNvSpPr>
+            <a:spLocks noGrp="1"/>
+          </p:cNvSpPr>
+          <p:nvPr>
+            <p:ph type="sldNum" sz="quarter" idx="12"/>
+          </p:nvPr>
+        </p:nvSpPr>
+        <p:spPr/>
+        <p:txBody>
+          <a:bodyPr/>
+          <a:lstStyle/>
+          <a:p>
+            <a:fld id="{DF323A44-C1E5-0B49-AAF6-7E9549B7BFD2}" type="slidenum">
+              <a:rPr lang="en-US" smtClean="0"/>
+              <a:t>22</a:t>
+            </a:fld>
+            <a:endParaRPr lang="en-US"/>
           </a:p>
         </p:txBody>
       </p:sp>
@@ -7895,12 +9405,12 @@
   </p:clrMapOvr>
   <mc:AlternateContent xmlns:mc="http://schemas.openxmlformats.org/markup-compatibility/2006" xmlns:p14="http://schemas.microsoft.com/office/powerpoint/2010/main">
     <mc:Choice Requires="p14">
-      <p:transition spd="slow" p14:dur="1200">
-        <p14:prism/>
+      <p:transition spd="slow" p14:dur="2000">
+        <p14:prism isContent="1"/>
       </p:transition>
     </mc:Choice>
     <mc:Fallback xmlns="">
-      <p:transition xmlns:p14="http://schemas.microsoft.com/office/powerpoint/2010/main" spd="slow">
+      <p:transition spd="slow">
         <p:fade/>
       </p:transition>
     </mc:Fallback>
@@ -7943,7 +9453,9 @@
         </p:nvSpPr>
         <p:spPr/>
         <p:txBody>
-          <a:bodyPr/>
+          <a:bodyPr>
+            <a:normAutofit fontScale="90000"/>
+          </a:bodyPr>
           <a:lstStyle/>
           <a:p>
             <a:r>
@@ -7991,6 +9503,92 @@
               <a:rPr lang="en-US" dirty="0"/>
               <a:t>E.g., menu vs. hamburger</a:t>
             </a:r>
+          </a:p>
+        </p:txBody>
+      </p:sp>
+      <p:sp>
+        <p:nvSpPr>
+          <p:cNvPr id="4" name="Date Placeholder 3">
+            <a:extLst>
+              <a:ext uri="{FF2B5EF4-FFF2-40B4-BE49-F238E27FC236}">
+                <a16:creationId xmlns:a16="http://schemas.microsoft.com/office/drawing/2014/main" id="{F6CC7269-18FE-A487-796E-286D2E9D2F9E}"/>
+              </a:ext>
+            </a:extLst>
+          </p:cNvPr>
+          <p:cNvSpPr>
+            <a:spLocks noGrp="1"/>
+          </p:cNvSpPr>
+          <p:nvPr>
+            <p:ph type="dt" sz="half" idx="10"/>
+          </p:nvPr>
+        </p:nvSpPr>
+        <p:spPr/>
+        <p:txBody>
+          <a:bodyPr/>
+          <a:lstStyle/>
+          <a:p>
+            <a:fld id="{FBF4CD1E-0B0E-CE4D-B6AC-D8F996642D51}" type="datetime1">
+              <a:rPr lang="en-US" smtClean="0"/>
+              <a:t>10/8/26</a:t>
+            </a:fld>
+            <a:endParaRPr lang="en-US"/>
+          </a:p>
+        </p:txBody>
+      </p:sp>
+      <p:sp>
+        <p:nvSpPr>
+          <p:cNvPr id="5" name="Footer Placeholder 4">
+            <a:extLst>
+              <a:ext uri="{FF2B5EF4-FFF2-40B4-BE49-F238E27FC236}">
+                <a16:creationId xmlns:a16="http://schemas.microsoft.com/office/drawing/2014/main" id="{30DC593B-567C-63E2-FDDB-A492F1276B63}"/>
+              </a:ext>
+            </a:extLst>
+          </p:cNvPr>
+          <p:cNvSpPr>
+            <a:spLocks noGrp="1"/>
+          </p:cNvSpPr>
+          <p:nvPr>
+            <p:ph type="ftr" sz="quarter" idx="11"/>
+          </p:nvPr>
+        </p:nvSpPr>
+        <p:spPr/>
+        <p:txBody>
+          <a:bodyPr/>
+          <a:lstStyle/>
+          <a:p>
+            <a:r>
+              <a:rPr lang="en-US"/>
+              <a:t>© Steve Beaty and others as cited</a:t>
+            </a:r>
+          </a:p>
+        </p:txBody>
+      </p:sp>
+      <p:sp>
+        <p:nvSpPr>
+          <p:cNvPr id="6" name="Slide Number Placeholder 5">
+            <a:extLst>
+              <a:ext uri="{FF2B5EF4-FFF2-40B4-BE49-F238E27FC236}">
+                <a16:creationId xmlns:a16="http://schemas.microsoft.com/office/drawing/2014/main" id="{039643CC-35A1-CD7E-BFAB-E41216BDE8C2}"/>
+              </a:ext>
+            </a:extLst>
+          </p:cNvPr>
+          <p:cNvSpPr>
+            <a:spLocks noGrp="1"/>
+          </p:cNvSpPr>
+          <p:nvPr>
+            <p:ph type="sldNum" sz="quarter" idx="12"/>
+          </p:nvPr>
+        </p:nvSpPr>
+        <p:spPr/>
+        <p:txBody>
+          <a:bodyPr/>
+          <a:lstStyle/>
+          <a:p>
+            <a:fld id="{DF323A44-C1E5-0B49-AAF6-7E9549B7BFD2}" type="slidenum">
+              <a:rPr lang="en-US" smtClean="0"/>
+              <a:t>23</a:t>
+            </a:fld>
+            <a:endParaRPr lang="en-US"/>
           </a:p>
         </p:txBody>
       </p:sp>
@@ -8006,12 +9604,12 @@
   </p:clrMapOvr>
   <mc:AlternateContent xmlns:mc="http://schemas.openxmlformats.org/markup-compatibility/2006" xmlns:p14="http://schemas.microsoft.com/office/powerpoint/2010/main">
     <mc:Choice Requires="p14">
-      <p:transition spd="slow" p14:dur="1200">
-        <p14:prism/>
+      <p:transition spd="slow" p14:dur="2000">
+        <p14:prism isContent="1"/>
       </p:transition>
     </mc:Choice>
     <mc:Fallback xmlns="">
-      <p:transition xmlns:p14="http://schemas.microsoft.com/office/powerpoint/2010/main" spd="slow">
+      <p:transition spd="slow">
         <p:fade/>
       </p:transition>
     </mc:Fallback>
@@ -8054,7 +9652,9 @@
         </p:nvSpPr>
         <p:spPr/>
         <p:txBody>
-          <a:bodyPr/>
+          <a:bodyPr>
+            <a:normAutofit fontScale="90000"/>
+          </a:bodyPr>
           <a:lstStyle/>
           <a:p>
             <a:r>
@@ -8158,6 +9758,92 @@
           </a:p>
           <a:p>
             <a:endParaRPr lang="en-US" dirty="0"/>
+          </a:p>
+        </p:txBody>
+      </p:sp>
+      <p:sp>
+        <p:nvSpPr>
+          <p:cNvPr id="4" name="Date Placeholder 3">
+            <a:extLst>
+              <a:ext uri="{FF2B5EF4-FFF2-40B4-BE49-F238E27FC236}">
+                <a16:creationId xmlns:a16="http://schemas.microsoft.com/office/drawing/2014/main" id="{EE7B3795-34C1-F2A4-A70C-B38CD1799E61}"/>
+              </a:ext>
+            </a:extLst>
+          </p:cNvPr>
+          <p:cNvSpPr>
+            <a:spLocks noGrp="1"/>
+          </p:cNvSpPr>
+          <p:nvPr>
+            <p:ph type="dt" sz="half" idx="10"/>
+          </p:nvPr>
+        </p:nvSpPr>
+        <p:spPr/>
+        <p:txBody>
+          <a:bodyPr/>
+          <a:lstStyle/>
+          <a:p>
+            <a:fld id="{23DACF1B-4B08-B74D-9BB0-08D9597D5D0C}" type="datetime1">
+              <a:rPr lang="en-US" smtClean="0"/>
+              <a:t>10/8/26</a:t>
+            </a:fld>
+            <a:endParaRPr lang="en-US"/>
+          </a:p>
+        </p:txBody>
+      </p:sp>
+      <p:sp>
+        <p:nvSpPr>
+          <p:cNvPr id="5" name="Footer Placeholder 4">
+            <a:extLst>
+              <a:ext uri="{FF2B5EF4-FFF2-40B4-BE49-F238E27FC236}">
+                <a16:creationId xmlns:a16="http://schemas.microsoft.com/office/drawing/2014/main" id="{87B448A2-D132-20A4-CFD1-3930BAFF95BF}"/>
+              </a:ext>
+            </a:extLst>
+          </p:cNvPr>
+          <p:cNvSpPr>
+            <a:spLocks noGrp="1"/>
+          </p:cNvSpPr>
+          <p:nvPr>
+            <p:ph type="ftr" sz="quarter" idx="11"/>
+          </p:nvPr>
+        </p:nvSpPr>
+        <p:spPr/>
+        <p:txBody>
+          <a:bodyPr/>
+          <a:lstStyle/>
+          <a:p>
+            <a:r>
+              <a:rPr lang="en-US"/>
+              <a:t>© Steve Beaty and others as cited</a:t>
+            </a:r>
+          </a:p>
+        </p:txBody>
+      </p:sp>
+      <p:sp>
+        <p:nvSpPr>
+          <p:cNvPr id="6" name="Slide Number Placeholder 5">
+            <a:extLst>
+              <a:ext uri="{FF2B5EF4-FFF2-40B4-BE49-F238E27FC236}">
+                <a16:creationId xmlns:a16="http://schemas.microsoft.com/office/drawing/2014/main" id="{E0B84012-167A-ED19-F64C-2079E21935E7}"/>
+              </a:ext>
+            </a:extLst>
+          </p:cNvPr>
+          <p:cNvSpPr>
+            <a:spLocks noGrp="1"/>
+          </p:cNvSpPr>
+          <p:nvPr>
+            <p:ph type="sldNum" sz="quarter" idx="12"/>
+          </p:nvPr>
+        </p:nvSpPr>
+        <p:spPr/>
+        <p:txBody>
+          <a:bodyPr/>
+          <a:lstStyle/>
+          <a:p>
+            <a:fld id="{DF323A44-C1E5-0B49-AAF6-7E9549B7BFD2}" type="slidenum">
+              <a:rPr lang="en-US" smtClean="0"/>
+              <a:t>24</a:t>
+            </a:fld>
+            <a:endParaRPr lang="en-US"/>
           </a:p>
         </p:txBody>
       </p:sp>
@@ -8221,7 +9907,9 @@
         </p:nvSpPr>
         <p:spPr/>
         <p:txBody>
-          <a:bodyPr/>
+          <a:bodyPr>
+            <a:normAutofit fontScale="90000"/>
+          </a:bodyPr>
           <a:lstStyle/>
           <a:p>
             <a:r>
@@ -8283,6 +9971,92 @@
               </a:rPr>
               <a:t>./bin/dev</a:t>
             </a:r>
+          </a:p>
+        </p:txBody>
+      </p:sp>
+      <p:sp>
+        <p:nvSpPr>
+          <p:cNvPr id="3" name="Date Placeholder 2">
+            <a:extLst>
+              <a:ext uri="{FF2B5EF4-FFF2-40B4-BE49-F238E27FC236}">
+                <a16:creationId xmlns:a16="http://schemas.microsoft.com/office/drawing/2014/main" id="{03DDF4C8-EC16-B864-0373-0B627388C12B}"/>
+              </a:ext>
+            </a:extLst>
+          </p:cNvPr>
+          <p:cNvSpPr>
+            <a:spLocks noGrp="1"/>
+          </p:cNvSpPr>
+          <p:nvPr>
+            <p:ph type="dt" sz="half" idx="10"/>
+          </p:nvPr>
+        </p:nvSpPr>
+        <p:spPr/>
+        <p:txBody>
+          <a:bodyPr/>
+          <a:lstStyle/>
+          <a:p>
+            <a:fld id="{150E85FF-3CFF-3E48-8F83-05377E2A1EC9}" type="datetime1">
+              <a:rPr lang="en-US" smtClean="0"/>
+              <a:t>10/8/26</a:t>
+            </a:fld>
+            <a:endParaRPr lang="en-US"/>
+          </a:p>
+        </p:txBody>
+      </p:sp>
+      <p:sp>
+        <p:nvSpPr>
+          <p:cNvPr id="5" name="Footer Placeholder 4">
+            <a:extLst>
+              <a:ext uri="{FF2B5EF4-FFF2-40B4-BE49-F238E27FC236}">
+                <a16:creationId xmlns:a16="http://schemas.microsoft.com/office/drawing/2014/main" id="{1D14D023-6F76-E97E-7651-F973FB109DD8}"/>
+              </a:ext>
+            </a:extLst>
+          </p:cNvPr>
+          <p:cNvSpPr>
+            <a:spLocks noGrp="1"/>
+          </p:cNvSpPr>
+          <p:nvPr>
+            <p:ph type="ftr" sz="quarter" idx="11"/>
+          </p:nvPr>
+        </p:nvSpPr>
+        <p:spPr/>
+        <p:txBody>
+          <a:bodyPr/>
+          <a:lstStyle/>
+          <a:p>
+            <a:r>
+              <a:rPr lang="en-US"/>
+              <a:t>© Steve Beaty and others as cited</a:t>
+            </a:r>
+          </a:p>
+        </p:txBody>
+      </p:sp>
+      <p:sp>
+        <p:nvSpPr>
+          <p:cNvPr id="6" name="Slide Number Placeholder 5">
+            <a:extLst>
+              <a:ext uri="{FF2B5EF4-FFF2-40B4-BE49-F238E27FC236}">
+                <a16:creationId xmlns:a16="http://schemas.microsoft.com/office/drawing/2014/main" id="{83F0ADF3-51F7-6C88-AC6E-144BB148811E}"/>
+              </a:ext>
+            </a:extLst>
+          </p:cNvPr>
+          <p:cNvSpPr>
+            <a:spLocks noGrp="1"/>
+          </p:cNvSpPr>
+          <p:nvPr>
+            <p:ph type="sldNum" sz="quarter" idx="12"/>
+          </p:nvPr>
+        </p:nvSpPr>
+        <p:spPr/>
+        <p:txBody>
+          <a:bodyPr/>
+          <a:lstStyle/>
+          <a:p>
+            <a:fld id="{DF323A44-C1E5-0B49-AAF6-7E9549B7BFD2}" type="slidenum">
+              <a:rPr lang="en-US" smtClean="0"/>
+              <a:t>25</a:t>
+            </a:fld>
+            <a:endParaRPr lang="en-US"/>
           </a:p>
         </p:txBody>
       </p:sp>
@@ -8298,12 +10072,12 @@
   </p:clrMapOvr>
   <mc:AlternateContent xmlns:mc="http://schemas.openxmlformats.org/markup-compatibility/2006" xmlns:p14="http://schemas.microsoft.com/office/powerpoint/2010/main">
     <mc:Choice Requires="p14">
-      <p:transition spd="slow" p14:dur="1200">
-        <p14:prism/>
+      <p:transition spd="slow" p14:dur="2000">
+        <p14:prism isContent="1"/>
       </p:transition>
     </mc:Choice>
     <mc:Fallback xmlns="">
-      <p:transition xmlns:p14="http://schemas.microsoft.com/office/powerpoint/2010/main" spd="slow">
+      <p:transition spd="slow">
         <p:fade/>
       </p:transition>
     </mc:Fallback>
@@ -8346,7 +10120,9 @@
         </p:nvSpPr>
         <p:spPr/>
         <p:txBody>
-          <a:bodyPr/>
+          <a:bodyPr>
+            <a:normAutofit fontScale="90000"/>
+          </a:bodyPr>
           <a:lstStyle/>
           <a:p>
             <a:r>
@@ -8374,7 +10150,9 @@
         </p:nvSpPr>
         <p:spPr/>
         <p:txBody>
-          <a:bodyPr/>
+          <a:bodyPr>
+            <a:normAutofit lnSpcReduction="10000"/>
+          </a:bodyPr>
           <a:lstStyle/>
           <a:p>
             <a:r>
@@ -8401,6 +10179,92 @@
               <a:rPr lang="en-US" dirty="0"/>
               <a:t>No additional requests needed</a:t>
             </a:r>
+          </a:p>
+        </p:txBody>
+      </p:sp>
+      <p:sp>
+        <p:nvSpPr>
+          <p:cNvPr id="4" name="Date Placeholder 3">
+            <a:extLst>
+              <a:ext uri="{FF2B5EF4-FFF2-40B4-BE49-F238E27FC236}">
+                <a16:creationId xmlns:a16="http://schemas.microsoft.com/office/drawing/2014/main" id="{09E734FA-708B-0946-9916-E0FFCD8FDC50}"/>
+              </a:ext>
+            </a:extLst>
+          </p:cNvPr>
+          <p:cNvSpPr>
+            <a:spLocks noGrp="1"/>
+          </p:cNvSpPr>
+          <p:nvPr>
+            <p:ph type="dt" sz="half" idx="10"/>
+          </p:nvPr>
+        </p:nvSpPr>
+        <p:spPr/>
+        <p:txBody>
+          <a:bodyPr/>
+          <a:lstStyle/>
+          <a:p>
+            <a:fld id="{DFF3CCF6-9DD5-7944-99F3-DF3412A0C717}" type="datetime1">
+              <a:rPr lang="en-US" smtClean="0"/>
+              <a:t>10/8/26</a:t>
+            </a:fld>
+            <a:endParaRPr lang="en-US"/>
+          </a:p>
+        </p:txBody>
+      </p:sp>
+      <p:sp>
+        <p:nvSpPr>
+          <p:cNvPr id="5" name="Footer Placeholder 4">
+            <a:extLst>
+              <a:ext uri="{FF2B5EF4-FFF2-40B4-BE49-F238E27FC236}">
+                <a16:creationId xmlns:a16="http://schemas.microsoft.com/office/drawing/2014/main" id="{8E88C67A-34A2-34C9-2123-EB7CC9392DCD}"/>
+              </a:ext>
+            </a:extLst>
+          </p:cNvPr>
+          <p:cNvSpPr>
+            <a:spLocks noGrp="1"/>
+          </p:cNvSpPr>
+          <p:nvPr>
+            <p:ph type="ftr" sz="quarter" idx="11"/>
+          </p:nvPr>
+        </p:nvSpPr>
+        <p:spPr/>
+        <p:txBody>
+          <a:bodyPr/>
+          <a:lstStyle/>
+          <a:p>
+            <a:r>
+              <a:rPr lang="en-US"/>
+              <a:t>© Steve Beaty and others as cited</a:t>
+            </a:r>
+          </a:p>
+        </p:txBody>
+      </p:sp>
+      <p:sp>
+        <p:nvSpPr>
+          <p:cNvPr id="6" name="Slide Number Placeholder 5">
+            <a:extLst>
+              <a:ext uri="{FF2B5EF4-FFF2-40B4-BE49-F238E27FC236}">
+                <a16:creationId xmlns:a16="http://schemas.microsoft.com/office/drawing/2014/main" id="{94834ACA-DFC1-112C-48EB-6067A518F6ED}"/>
+              </a:ext>
+            </a:extLst>
+          </p:cNvPr>
+          <p:cNvSpPr>
+            <a:spLocks noGrp="1"/>
+          </p:cNvSpPr>
+          <p:nvPr>
+            <p:ph type="sldNum" sz="quarter" idx="12"/>
+          </p:nvPr>
+        </p:nvSpPr>
+        <p:spPr/>
+        <p:txBody>
+          <a:bodyPr/>
+          <a:lstStyle/>
+          <a:p>
+            <a:fld id="{DF323A44-C1E5-0B49-AAF6-7E9549B7BFD2}" type="slidenum">
+              <a:rPr lang="en-US" smtClean="0"/>
+              <a:t>26</a:t>
+            </a:fld>
+            <a:endParaRPr lang="en-US"/>
           </a:p>
         </p:txBody>
       </p:sp>
@@ -8416,12 +10280,12 @@
   </p:clrMapOvr>
   <mc:AlternateContent xmlns:mc="http://schemas.openxmlformats.org/markup-compatibility/2006" xmlns:p14="http://schemas.microsoft.com/office/powerpoint/2010/main">
     <mc:Choice Requires="p14">
-      <p:transition spd="slow" p14:dur="1200">
-        <p14:prism/>
+      <p:transition spd="slow" p14:dur="2000">
+        <p14:prism isContent="1"/>
       </p:transition>
     </mc:Choice>
     <mc:Fallback xmlns="">
-      <p:transition xmlns:p14="http://schemas.microsoft.com/office/powerpoint/2010/main" spd="slow">
+      <p:transition spd="slow">
         <p:fade/>
       </p:transition>
     </mc:Fallback>
@@ -8464,7 +10328,9 @@
         </p:nvSpPr>
         <p:spPr/>
         <p:txBody>
-          <a:bodyPr/>
+          <a:bodyPr>
+            <a:normAutofit fontScale="90000"/>
+          </a:bodyPr>
           <a:lstStyle/>
           <a:p>
             <a:r>
@@ -8493,7 +10359,7 @@
         <p:spPr/>
         <p:txBody>
           <a:bodyPr>
-            <a:normAutofit lnSpcReduction="10000"/>
+            <a:normAutofit fontScale="92500"/>
           </a:bodyPr>
           <a:lstStyle/>
           <a:p>
@@ -8536,6 +10402,92 @@
               <a:rPr lang="en-US" dirty="0"/>
               <a:t>Ethical</a:t>
             </a:r>
+          </a:p>
+        </p:txBody>
+      </p:sp>
+      <p:sp>
+        <p:nvSpPr>
+          <p:cNvPr id="4" name="Date Placeholder 3">
+            <a:extLst>
+              <a:ext uri="{FF2B5EF4-FFF2-40B4-BE49-F238E27FC236}">
+                <a16:creationId xmlns:a16="http://schemas.microsoft.com/office/drawing/2014/main" id="{8881017E-289B-97B5-B1AD-E5F7C67B0DAD}"/>
+              </a:ext>
+            </a:extLst>
+          </p:cNvPr>
+          <p:cNvSpPr>
+            <a:spLocks noGrp="1"/>
+          </p:cNvSpPr>
+          <p:nvPr>
+            <p:ph type="dt" sz="half" idx="10"/>
+          </p:nvPr>
+        </p:nvSpPr>
+        <p:spPr/>
+        <p:txBody>
+          <a:bodyPr/>
+          <a:lstStyle/>
+          <a:p>
+            <a:fld id="{4EEAE376-5E6B-094C-8715-FE9FB7076379}" type="datetime1">
+              <a:rPr lang="en-US" smtClean="0"/>
+              <a:t>10/8/26</a:t>
+            </a:fld>
+            <a:endParaRPr lang="en-US"/>
+          </a:p>
+        </p:txBody>
+      </p:sp>
+      <p:sp>
+        <p:nvSpPr>
+          <p:cNvPr id="5" name="Footer Placeholder 4">
+            <a:extLst>
+              <a:ext uri="{FF2B5EF4-FFF2-40B4-BE49-F238E27FC236}">
+                <a16:creationId xmlns:a16="http://schemas.microsoft.com/office/drawing/2014/main" id="{8025A4C2-CE9C-832F-13D6-B011CABD74BF}"/>
+              </a:ext>
+            </a:extLst>
+          </p:cNvPr>
+          <p:cNvSpPr>
+            <a:spLocks noGrp="1"/>
+          </p:cNvSpPr>
+          <p:nvPr>
+            <p:ph type="ftr" sz="quarter" idx="11"/>
+          </p:nvPr>
+        </p:nvSpPr>
+        <p:spPr/>
+        <p:txBody>
+          <a:bodyPr/>
+          <a:lstStyle/>
+          <a:p>
+            <a:r>
+              <a:rPr lang="en-US"/>
+              <a:t>© Steve Beaty and others as cited</a:t>
+            </a:r>
+          </a:p>
+        </p:txBody>
+      </p:sp>
+      <p:sp>
+        <p:nvSpPr>
+          <p:cNvPr id="6" name="Slide Number Placeholder 5">
+            <a:extLst>
+              <a:ext uri="{FF2B5EF4-FFF2-40B4-BE49-F238E27FC236}">
+                <a16:creationId xmlns:a16="http://schemas.microsoft.com/office/drawing/2014/main" id="{6C3D3026-AB21-68D4-EBAB-46F33D8ADBE6}"/>
+              </a:ext>
+            </a:extLst>
+          </p:cNvPr>
+          <p:cNvSpPr>
+            <a:spLocks noGrp="1"/>
+          </p:cNvSpPr>
+          <p:nvPr>
+            <p:ph type="sldNum" sz="quarter" idx="12"/>
+          </p:nvPr>
+        </p:nvSpPr>
+        <p:spPr/>
+        <p:txBody>
+          <a:bodyPr/>
+          <a:lstStyle/>
+          <a:p>
+            <a:fld id="{DF323A44-C1E5-0B49-AAF6-7E9549B7BFD2}" type="slidenum">
+              <a:rPr lang="en-US" smtClean="0"/>
+              <a:t>3</a:t>
+            </a:fld>
+            <a:endParaRPr lang="en-US"/>
           </a:p>
         </p:txBody>
       </p:sp>
@@ -8551,12 +10503,12 @@
   </p:clrMapOvr>
   <mc:AlternateContent xmlns:mc="http://schemas.openxmlformats.org/markup-compatibility/2006" xmlns:p14="http://schemas.microsoft.com/office/powerpoint/2010/main">
     <mc:Choice Requires="p14">
-      <p:transition spd="slow" p14:dur="1200">
-        <p14:prism/>
+      <p:transition spd="slow" p14:dur="2000">
+        <p14:prism isContent="1"/>
       </p:transition>
     </mc:Choice>
     <mc:Fallback xmlns="">
-      <p:transition xmlns:p14="http://schemas.microsoft.com/office/powerpoint/2010/main" spd="slow">
+      <p:transition spd="slow">
         <p:fade/>
       </p:transition>
     </mc:Fallback>
@@ -8599,7 +10551,9 @@
         </p:nvSpPr>
         <p:spPr/>
         <p:txBody>
-          <a:bodyPr/>
+          <a:bodyPr>
+            <a:normAutofit fontScale="90000"/>
+          </a:bodyPr>
           <a:lstStyle/>
           <a:p>
             <a:r>
@@ -8628,7 +10582,7 @@
         <p:spPr/>
         <p:txBody>
           <a:bodyPr>
-            <a:normAutofit fontScale="92500" lnSpcReduction="20000"/>
+            <a:normAutofit fontScale="77500" lnSpcReduction="20000"/>
           </a:bodyPr>
           <a:lstStyle/>
           <a:p>
@@ -8682,6 +10636,92 @@
               <a:rPr lang="en-US" dirty="0"/>
               <a:t>Accessible on many devices</a:t>
             </a:r>
+          </a:p>
+        </p:txBody>
+      </p:sp>
+      <p:sp>
+        <p:nvSpPr>
+          <p:cNvPr id="4" name="Date Placeholder 3">
+            <a:extLst>
+              <a:ext uri="{FF2B5EF4-FFF2-40B4-BE49-F238E27FC236}">
+                <a16:creationId xmlns:a16="http://schemas.microsoft.com/office/drawing/2014/main" id="{0E6D3550-B7DC-9800-80C7-42EC67ED8186}"/>
+              </a:ext>
+            </a:extLst>
+          </p:cNvPr>
+          <p:cNvSpPr>
+            <a:spLocks noGrp="1"/>
+          </p:cNvSpPr>
+          <p:nvPr>
+            <p:ph type="dt" sz="half" idx="10"/>
+          </p:nvPr>
+        </p:nvSpPr>
+        <p:spPr/>
+        <p:txBody>
+          <a:bodyPr/>
+          <a:lstStyle/>
+          <a:p>
+            <a:fld id="{F6BCEC7F-10CF-5D44-980E-30B7229CD197}" type="datetime1">
+              <a:rPr lang="en-US" smtClean="0"/>
+              <a:t>10/8/26</a:t>
+            </a:fld>
+            <a:endParaRPr lang="en-US"/>
+          </a:p>
+        </p:txBody>
+      </p:sp>
+      <p:sp>
+        <p:nvSpPr>
+          <p:cNvPr id="5" name="Footer Placeholder 4">
+            <a:extLst>
+              <a:ext uri="{FF2B5EF4-FFF2-40B4-BE49-F238E27FC236}">
+                <a16:creationId xmlns:a16="http://schemas.microsoft.com/office/drawing/2014/main" id="{265C5AB6-B1BF-99AB-BB0D-DE0E0AF2F0BD}"/>
+              </a:ext>
+            </a:extLst>
+          </p:cNvPr>
+          <p:cNvSpPr>
+            <a:spLocks noGrp="1"/>
+          </p:cNvSpPr>
+          <p:nvPr>
+            <p:ph type="ftr" sz="quarter" idx="11"/>
+          </p:nvPr>
+        </p:nvSpPr>
+        <p:spPr/>
+        <p:txBody>
+          <a:bodyPr/>
+          <a:lstStyle/>
+          <a:p>
+            <a:r>
+              <a:rPr lang="en-US"/>
+              <a:t>© Steve Beaty and others as cited</a:t>
+            </a:r>
+          </a:p>
+        </p:txBody>
+      </p:sp>
+      <p:sp>
+        <p:nvSpPr>
+          <p:cNvPr id="6" name="Slide Number Placeholder 5">
+            <a:extLst>
+              <a:ext uri="{FF2B5EF4-FFF2-40B4-BE49-F238E27FC236}">
+                <a16:creationId xmlns:a16="http://schemas.microsoft.com/office/drawing/2014/main" id="{7A6714FD-2F17-F02C-EA1E-65B79595DE5C}"/>
+              </a:ext>
+            </a:extLst>
+          </p:cNvPr>
+          <p:cNvSpPr>
+            <a:spLocks noGrp="1"/>
+          </p:cNvSpPr>
+          <p:nvPr>
+            <p:ph type="sldNum" sz="quarter" idx="12"/>
+          </p:nvPr>
+        </p:nvSpPr>
+        <p:spPr/>
+        <p:txBody>
+          <a:bodyPr/>
+          <a:lstStyle/>
+          <a:p>
+            <a:fld id="{DF323A44-C1E5-0B49-AAF6-7E9549B7BFD2}" type="slidenum">
+              <a:rPr lang="en-US" smtClean="0"/>
+              <a:t>4</a:t>
+            </a:fld>
+            <a:endParaRPr lang="en-US"/>
           </a:p>
         </p:txBody>
       </p:sp>
@@ -8697,12 +10737,12 @@
   </p:clrMapOvr>
   <mc:AlternateContent xmlns:mc="http://schemas.openxmlformats.org/markup-compatibility/2006" xmlns:p14="http://schemas.microsoft.com/office/powerpoint/2010/main">
     <mc:Choice Requires="p14">
-      <p:transition spd="slow" p14:dur="1200">
-        <p14:prism/>
+      <p:transition spd="slow" p14:dur="2000">
+        <p14:prism isContent="1"/>
       </p:transition>
     </mc:Choice>
     <mc:Fallback xmlns="">
-      <p:transition xmlns:p14="http://schemas.microsoft.com/office/powerpoint/2010/main" spd="slow">
+      <p:transition spd="slow">
         <p:fade/>
       </p:transition>
     </mc:Fallback>
@@ -8745,7 +10785,9 @@
         </p:nvSpPr>
         <p:spPr/>
         <p:txBody>
-          <a:bodyPr/>
+          <a:bodyPr>
+            <a:normAutofit fontScale="90000"/>
+          </a:bodyPr>
           <a:lstStyle/>
           <a:p>
             <a:r>
@@ -8812,6 +10854,92 @@
               <a:rPr lang="en-US" dirty="0"/>
               <a:t>/</a:t>
             </a:r>
+          </a:p>
+        </p:txBody>
+      </p:sp>
+      <p:sp>
+        <p:nvSpPr>
+          <p:cNvPr id="4" name="Date Placeholder 3">
+            <a:extLst>
+              <a:ext uri="{FF2B5EF4-FFF2-40B4-BE49-F238E27FC236}">
+                <a16:creationId xmlns:a16="http://schemas.microsoft.com/office/drawing/2014/main" id="{9AD12B23-C476-BFE1-9817-381583F22A4B}"/>
+              </a:ext>
+            </a:extLst>
+          </p:cNvPr>
+          <p:cNvSpPr>
+            <a:spLocks noGrp="1"/>
+          </p:cNvSpPr>
+          <p:nvPr>
+            <p:ph type="dt" sz="half" idx="10"/>
+          </p:nvPr>
+        </p:nvSpPr>
+        <p:spPr/>
+        <p:txBody>
+          <a:bodyPr/>
+          <a:lstStyle/>
+          <a:p>
+            <a:fld id="{1C426D6A-FE49-3C47-A560-00E7510F5564}" type="datetime1">
+              <a:rPr lang="en-US" smtClean="0"/>
+              <a:t>10/8/26</a:t>
+            </a:fld>
+            <a:endParaRPr lang="en-US"/>
+          </a:p>
+        </p:txBody>
+      </p:sp>
+      <p:sp>
+        <p:nvSpPr>
+          <p:cNvPr id="5" name="Footer Placeholder 4">
+            <a:extLst>
+              <a:ext uri="{FF2B5EF4-FFF2-40B4-BE49-F238E27FC236}">
+                <a16:creationId xmlns:a16="http://schemas.microsoft.com/office/drawing/2014/main" id="{ED396BB5-D4EC-6EFD-8B8A-5F91C1775CC9}"/>
+              </a:ext>
+            </a:extLst>
+          </p:cNvPr>
+          <p:cNvSpPr>
+            <a:spLocks noGrp="1"/>
+          </p:cNvSpPr>
+          <p:nvPr>
+            <p:ph type="ftr" sz="quarter" idx="11"/>
+          </p:nvPr>
+        </p:nvSpPr>
+        <p:spPr/>
+        <p:txBody>
+          <a:bodyPr/>
+          <a:lstStyle/>
+          <a:p>
+            <a:r>
+              <a:rPr lang="en-US"/>
+              <a:t>© Steve Beaty and others as cited</a:t>
+            </a:r>
+          </a:p>
+        </p:txBody>
+      </p:sp>
+      <p:sp>
+        <p:nvSpPr>
+          <p:cNvPr id="6" name="Slide Number Placeholder 5">
+            <a:extLst>
+              <a:ext uri="{FF2B5EF4-FFF2-40B4-BE49-F238E27FC236}">
+                <a16:creationId xmlns:a16="http://schemas.microsoft.com/office/drawing/2014/main" id="{E70A54A9-AEE0-E2F9-390A-33B911FFFF45}"/>
+              </a:ext>
+            </a:extLst>
+          </p:cNvPr>
+          <p:cNvSpPr>
+            <a:spLocks noGrp="1"/>
+          </p:cNvSpPr>
+          <p:nvPr>
+            <p:ph type="sldNum" sz="quarter" idx="12"/>
+          </p:nvPr>
+        </p:nvSpPr>
+        <p:spPr/>
+        <p:txBody>
+          <a:bodyPr/>
+          <a:lstStyle/>
+          <a:p>
+            <a:fld id="{DF323A44-C1E5-0B49-AAF6-7E9549B7BFD2}" type="slidenum">
+              <a:rPr lang="en-US" smtClean="0"/>
+              <a:t>5</a:t>
+            </a:fld>
+            <a:endParaRPr lang="en-US"/>
           </a:p>
         </p:txBody>
       </p:sp>
@@ -8827,12 +10955,12 @@
   </p:clrMapOvr>
   <mc:AlternateContent xmlns:mc="http://schemas.openxmlformats.org/markup-compatibility/2006" xmlns:p14="http://schemas.microsoft.com/office/powerpoint/2010/main">
     <mc:Choice Requires="p14">
-      <p:transition spd="slow" p14:dur="1200">
-        <p14:prism/>
+      <p:transition spd="slow" p14:dur="2000">
+        <p14:prism isContent="1"/>
       </p:transition>
     </mc:Choice>
     <mc:Fallback xmlns="">
-      <p:transition xmlns:p14="http://schemas.microsoft.com/office/powerpoint/2010/main" spd="slow">
+      <p:transition spd="slow">
         <p:fade/>
       </p:transition>
     </mc:Fallback>
@@ -8875,7 +11003,9 @@
         </p:nvSpPr>
         <p:spPr/>
         <p:txBody>
-          <a:bodyPr/>
+          <a:bodyPr>
+            <a:normAutofit fontScale="90000"/>
+          </a:bodyPr>
           <a:lstStyle/>
           <a:p>
             <a:r>
@@ -8951,6 +11081,92 @@
           </a:p>
           <a:p>
             <a:endParaRPr lang="en-US" dirty="0"/>
+          </a:p>
+        </p:txBody>
+      </p:sp>
+      <p:sp>
+        <p:nvSpPr>
+          <p:cNvPr id="4" name="Date Placeholder 3">
+            <a:extLst>
+              <a:ext uri="{FF2B5EF4-FFF2-40B4-BE49-F238E27FC236}">
+                <a16:creationId xmlns:a16="http://schemas.microsoft.com/office/drawing/2014/main" id="{1856466B-CC0C-5573-F66F-D027CD95E772}"/>
+              </a:ext>
+            </a:extLst>
+          </p:cNvPr>
+          <p:cNvSpPr>
+            <a:spLocks noGrp="1"/>
+          </p:cNvSpPr>
+          <p:nvPr>
+            <p:ph type="dt" sz="half" idx="10"/>
+          </p:nvPr>
+        </p:nvSpPr>
+        <p:spPr/>
+        <p:txBody>
+          <a:bodyPr/>
+          <a:lstStyle/>
+          <a:p>
+            <a:fld id="{2CF2508A-C8AB-0144-BA3E-27A5ECE1A790}" type="datetime1">
+              <a:rPr lang="en-US" smtClean="0"/>
+              <a:t>10/8/26</a:t>
+            </a:fld>
+            <a:endParaRPr lang="en-US"/>
+          </a:p>
+        </p:txBody>
+      </p:sp>
+      <p:sp>
+        <p:nvSpPr>
+          <p:cNvPr id="5" name="Footer Placeholder 4">
+            <a:extLst>
+              <a:ext uri="{FF2B5EF4-FFF2-40B4-BE49-F238E27FC236}">
+                <a16:creationId xmlns:a16="http://schemas.microsoft.com/office/drawing/2014/main" id="{F93E37F5-B7EC-583F-96F0-2FE9E60F94E3}"/>
+              </a:ext>
+            </a:extLst>
+          </p:cNvPr>
+          <p:cNvSpPr>
+            <a:spLocks noGrp="1"/>
+          </p:cNvSpPr>
+          <p:nvPr>
+            <p:ph type="ftr" sz="quarter" idx="11"/>
+          </p:nvPr>
+        </p:nvSpPr>
+        <p:spPr/>
+        <p:txBody>
+          <a:bodyPr/>
+          <a:lstStyle/>
+          <a:p>
+            <a:r>
+              <a:rPr lang="en-US"/>
+              <a:t>© Steve Beaty and others as cited</a:t>
+            </a:r>
+          </a:p>
+        </p:txBody>
+      </p:sp>
+      <p:sp>
+        <p:nvSpPr>
+          <p:cNvPr id="6" name="Slide Number Placeholder 5">
+            <a:extLst>
+              <a:ext uri="{FF2B5EF4-FFF2-40B4-BE49-F238E27FC236}">
+                <a16:creationId xmlns:a16="http://schemas.microsoft.com/office/drawing/2014/main" id="{D79364AC-EC0F-347F-8F99-15C68296486F}"/>
+              </a:ext>
+            </a:extLst>
+          </p:cNvPr>
+          <p:cNvSpPr>
+            <a:spLocks noGrp="1"/>
+          </p:cNvSpPr>
+          <p:nvPr>
+            <p:ph type="sldNum" sz="quarter" idx="12"/>
+          </p:nvPr>
+        </p:nvSpPr>
+        <p:spPr/>
+        <p:txBody>
+          <a:bodyPr/>
+          <a:lstStyle/>
+          <a:p>
+            <a:fld id="{DF323A44-C1E5-0B49-AAF6-7E9549B7BFD2}" type="slidenum">
+              <a:rPr lang="en-US" smtClean="0"/>
+              <a:t>6</a:t>
+            </a:fld>
+            <a:endParaRPr lang="en-US"/>
           </a:p>
         </p:txBody>
       </p:sp>
@@ -8966,12 +11182,12 @@
   </p:clrMapOvr>
   <mc:AlternateContent xmlns:mc="http://schemas.openxmlformats.org/markup-compatibility/2006" xmlns:p14="http://schemas.microsoft.com/office/powerpoint/2010/main">
     <mc:Choice Requires="p14">
-      <p:transition spd="slow" p14:dur="1200">
-        <p14:prism/>
+      <p:transition spd="slow" p14:dur="2000">
+        <p14:prism isContent="1"/>
       </p:transition>
     </mc:Choice>
     <mc:Fallback xmlns="">
-      <p:transition xmlns:p14="http://schemas.microsoft.com/office/powerpoint/2010/main" spd="slow">
+      <p:transition spd="slow">
         <p:fade/>
       </p:transition>
     </mc:Fallback>
@@ -9014,7 +11230,9 @@
         </p:nvSpPr>
         <p:spPr/>
         <p:txBody>
-          <a:bodyPr/>
+          <a:bodyPr>
+            <a:normAutofit fontScale="90000"/>
+          </a:bodyPr>
           <a:lstStyle/>
           <a:p>
             <a:r>
@@ -9042,7 +11260,9 @@
         </p:nvSpPr>
         <p:spPr/>
         <p:txBody>
-          <a:bodyPr/>
+          <a:bodyPr>
+            <a:normAutofit lnSpcReduction="10000"/>
+          </a:bodyPr>
           <a:lstStyle/>
           <a:p>
             <a:r>
@@ -9091,6 +11311,92 @@
               <a:rPr lang="en-US" dirty="0"/>
               <a:t>Comment out Ruby code </a:t>
             </a:r>
+          </a:p>
+        </p:txBody>
+      </p:sp>
+      <p:sp>
+        <p:nvSpPr>
+          <p:cNvPr id="4" name="Date Placeholder 3">
+            <a:extLst>
+              <a:ext uri="{FF2B5EF4-FFF2-40B4-BE49-F238E27FC236}">
+                <a16:creationId xmlns:a16="http://schemas.microsoft.com/office/drawing/2014/main" id="{B1EDF67F-1122-711F-8E11-4BDDD5ED992E}"/>
+              </a:ext>
+            </a:extLst>
+          </p:cNvPr>
+          <p:cNvSpPr>
+            <a:spLocks noGrp="1"/>
+          </p:cNvSpPr>
+          <p:nvPr>
+            <p:ph type="dt" sz="half" idx="10"/>
+          </p:nvPr>
+        </p:nvSpPr>
+        <p:spPr/>
+        <p:txBody>
+          <a:bodyPr/>
+          <a:lstStyle/>
+          <a:p>
+            <a:fld id="{BBAFA721-17B6-B94A-B5BA-BF18169C17D5}" type="datetime1">
+              <a:rPr lang="en-US" smtClean="0"/>
+              <a:t>10/8/26</a:t>
+            </a:fld>
+            <a:endParaRPr lang="en-US"/>
+          </a:p>
+        </p:txBody>
+      </p:sp>
+      <p:sp>
+        <p:nvSpPr>
+          <p:cNvPr id="5" name="Footer Placeholder 4">
+            <a:extLst>
+              <a:ext uri="{FF2B5EF4-FFF2-40B4-BE49-F238E27FC236}">
+                <a16:creationId xmlns:a16="http://schemas.microsoft.com/office/drawing/2014/main" id="{35B78967-878F-78DA-EFDF-4592DBAA44DF}"/>
+              </a:ext>
+            </a:extLst>
+          </p:cNvPr>
+          <p:cNvSpPr>
+            <a:spLocks noGrp="1"/>
+          </p:cNvSpPr>
+          <p:nvPr>
+            <p:ph type="ftr" sz="quarter" idx="11"/>
+          </p:nvPr>
+        </p:nvSpPr>
+        <p:spPr/>
+        <p:txBody>
+          <a:bodyPr/>
+          <a:lstStyle/>
+          <a:p>
+            <a:r>
+              <a:rPr lang="en-US"/>
+              <a:t>© Steve Beaty and others as cited</a:t>
+            </a:r>
+          </a:p>
+        </p:txBody>
+      </p:sp>
+      <p:sp>
+        <p:nvSpPr>
+          <p:cNvPr id="6" name="Slide Number Placeholder 5">
+            <a:extLst>
+              <a:ext uri="{FF2B5EF4-FFF2-40B4-BE49-F238E27FC236}">
+                <a16:creationId xmlns:a16="http://schemas.microsoft.com/office/drawing/2014/main" id="{6FA939A2-0841-1277-A395-0FCF8FD725BA}"/>
+              </a:ext>
+            </a:extLst>
+          </p:cNvPr>
+          <p:cNvSpPr>
+            <a:spLocks noGrp="1"/>
+          </p:cNvSpPr>
+          <p:nvPr>
+            <p:ph type="sldNum" sz="quarter" idx="12"/>
+          </p:nvPr>
+        </p:nvSpPr>
+        <p:spPr/>
+        <p:txBody>
+          <a:bodyPr/>
+          <a:lstStyle/>
+          <a:p>
+            <a:fld id="{DF323A44-C1E5-0B49-AAF6-7E9549B7BFD2}" type="slidenum">
+              <a:rPr lang="en-US" smtClean="0"/>
+              <a:t>7</a:t>
+            </a:fld>
+            <a:endParaRPr lang="en-US"/>
           </a:p>
         </p:txBody>
       </p:sp>
@@ -9106,12 +11412,12 @@
   </p:clrMapOvr>
   <mc:AlternateContent xmlns:mc="http://schemas.openxmlformats.org/markup-compatibility/2006" xmlns:p14="http://schemas.microsoft.com/office/powerpoint/2010/main">
     <mc:Choice Requires="p14">
-      <p:transition spd="slow" p14:dur="1200">
-        <p14:prism/>
+      <p:transition spd="slow" p14:dur="2000">
+        <p14:prism isContent="1"/>
       </p:transition>
     </mc:Choice>
     <mc:Fallback xmlns="">
-      <p:transition xmlns:p14="http://schemas.microsoft.com/office/powerpoint/2010/main" spd="slow">
+      <p:transition spd="slow">
         <p:fade/>
       </p:transition>
     </mc:Fallback>
@@ -9154,7 +11460,9 @@
         </p:nvSpPr>
         <p:spPr/>
         <p:txBody>
-          <a:bodyPr/>
+          <a:bodyPr>
+            <a:normAutofit fontScale="90000"/>
+          </a:bodyPr>
           <a:lstStyle/>
           <a:p>
             <a:r>
@@ -9222,6 +11530,92 @@
               <a:latin typeface="Courier New" panose="02070309020205020404" pitchFamily="49" charset="0"/>
               <a:cs typeface="Courier New" panose="02070309020205020404" pitchFamily="49" charset="0"/>
             </a:endParaRPr>
+          </a:p>
+        </p:txBody>
+      </p:sp>
+      <p:sp>
+        <p:nvSpPr>
+          <p:cNvPr id="4" name="Date Placeholder 3">
+            <a:extLst>
+              <a:ext uri="{FF2B5EF4-FFF2-40B4-BE49-F238E27FC236}">
+                <a16:creationId xmlns:a16="http://schemas.microsoft.com/office/drawing/2014/main" id="{9551137D-EE34-573F-1569-85508D263155}"/>
+              </a:ext>
+            </a:extLst>
+          </p:cNvPr>
+          <p:cNvSpPr>
+            <a:spLocks noGrp="1"/>
+          </p:cNvSpPr>
+          <p:nvPr>
+            <p:ph type="dt" sz="half" idx="10"/>
+          </p:nvPr>
+        </p:nvSpPr>
+        <p:spPr/>
+        <p:txBody>
+          <a:bodyPr/>
+          <a:lstStyle/>
+          <a:p>
+            <a:fld id="{3A03DEDB-E272-AC49-9172-D5762FEE681A}" type="datetime1">
+              <a:rPr lang="en-US" smtClean="0"/>
+              <a:t>10/8/26</a:t>
+            </a:fld>
+            <a:endParaRPr lang="en-US"/>
+          </a:p>
+        </p:txBody>
+      </p:sp>
+      <p:sp>
+        <p:nvSpPr>
+          <p:cNvPr id="5" name="Footer Placeholder 4">
+            <a:extLst>
+              <a:ext uri="{FF2B5EF4-FFF2-40B4-BE49-F238E27FC236}">
+                <a16:creationId xmlns:a16="http://schemas.microsoft.com/office/drawing/2014/main" id="{112EAE49-1E12-22B8-D538-E426CE30A25E}"/>
+              </a:ext>
+            </a:extLst>
+          </p:cNvPr>
+          <p:cNvSpPr>
+            <a:spLocks noGrp="1"/>
+          </p:cNvSpPr>
+          <p:nvPr>
+            <p:ph type="ftr" sz="quarter" idx="11"/>
+          </p:nvPr>
+        </p:nvSpPr>
+        <p:spPr/>
+        <p:txBody>
+          <a:bodyPr/>
+          <a:lstStyle/>
+          <a:p>
+            <a:r>
+              <a:rPr lang="en-US"/>
+              <a:t>© Steve Beaty and others as cited</a:t>
+            </a:r>
+          </a:p>
+        </p:txBody>
+      </p:sp>
+      <p:sp>
+        <p:nvSpPr>
+          <p:cNvPr id="6" name="Slide Number Placeholder 5">
+            <a:extLst>
+              <a:ext uri="{FF2B5EF4-FFF2-40B4-BE49-F238E27FC236}">
+                <a16:creationId xmlns:a16="http://schemas.microsoft.com/office/drawing/2014/main" id="{7C1B6CE9-8968-1020-38AD-E99830FA14AF}"/>
+              </a:ext>
+            </a:extLst>
+          </p:cNvPr>
+          <p:cNvSpPr>
+            <a:spLocks noGrp="1"/>
+          </p:cNvSpPr>
+          <p:nvPr>
+            <p:ph type="sldNum" sz="quarter" idx="12"/>
+          </p:nvPr>
+        </p:nvSpPr>
+        <p:spPr/>
+        <p:txBody>
+          <a:bodyPr/>
+          <a:lstStyle/>
+          <a:p>
+            <a:fld id="{DF323A44-C1E5-0B49-AAF6-7E9549B7BFD2}" type="slidenum">
+              <a:rPr lang="en-US" smtClean="0"/>
+              <a:t>8</a:t>
+            </a:fld>
+            <a:endParaRPr lang="en-US"/>
           </a:p>
         </p:txBody>
       </p:sp>
@@ -9237,12 +11631,12 @@
   </p:clrMapOvr>
   <mc:AlternateContent xmlns:mc="http://schemas.openxmlformats.org/markup-compatibility/2006" xmlns:p14="http://schemas.microsoft.com/office/powerpoint/2010/main">
     <mc:Choice Requires="p14">
-      <p:transition spd="slow" p14:dur="1200">
-        <p14:prism/>
+      <p:transition spd="slow" p14:dur="2000">
+        <p14:prism isContent="1"/>
       </p:transition>
     </mc:Choice>
     <mc:Fallback xmlns="">
-      <p:transition xmlns:p14="http://schemas.microsoft.com/office/powerpoint/2010/main" spd="slow">
+      <p:transition spd="slow">
         <p:fade/>
       </p:transition>
     </mc:Fallback>
@@ -9285,7 +11679,9 @@
         </p:nvSpPr>
         <p:spPr/>
         <p:txBody>
-          <a:bodyPr/>
+          <a:bodyPr>
+            <a:normAutofit fontScale="90000"/>
+          </a:bodyPr>
           <a:lstStyle/>
           <a:p>
             <a:r>
@@ -9314,7 +11710,7 @@
         <p:spPr/>
         <p:txBody>
           <a:bodyPr>
-            <a:normAutofit fontScale="62500" lnSpcReduction="20000"/>
+            <a:normAutofit fontScale="55000" lnSpcReduction="20000"/>
           </a:bodyPr>
           <a:lstStyle/>
           <a:p>
@@ -10512,6 +12908,92 @@
               <a:effectLst/>
               <a:latin typeface="Menlo" panose="020B0609030804020204" pitchFamily="49" charset="0"/>
             </a:endParaRPr>
+          </a:p>
+        </p:txBody>
+      </p:sp>
+      <p:sp>
+        <p:nvSpPr>
+          <p:cNvPr id="4" name="Date Placeholder 3">
+            <a:extLst>
+              <a:ext uri="{FF2B5EF4-FFF2-40B4-BE49-F238E27FC236}">
+                <a16:creationId xmlns:a16="http://schemas.microsoft.com/office/drawing/2014/main" id="{43F92528-8770-CD2B-2CC7-55D8CAB255F0}"/>
+              </a:ext>
+            </a:extLst>
+          </p:cNvPr>
+          <p:cNvSpPr>
+            <a:spLocks noGrp="1"/>
+          </p:cNvSpPr>
+          <p:nvPr>
+            <p:ph type="dt" sz="half" idx="10"/>
+          </p:nvPr>
+        </p:nvSpPr>
+        <p:spPr/>
+        <p:txBody>
+          <a:bodyPr/>
+          <a:lstStyle/>
+          <a:p>
+            <a:fld id="{B1A77C84-4BC4-5C4A-84B5-CED3EF7D0C62}" type="datetime1">
+              <a:rPr lang="en-US" smtClean="0"/>
+              <a:t>10/8/26</a:t>
+            </a:fld>
+            <a:endParaRPr lang="en-US"/>
+          </a:p>
+        </p:txBody>
+      </p:sp>
+      <p:sp>
+        <p:nvSpPr>
+          <p:cNvPr id="5" name="Footer Placeholder 4">
+            <a:extLst>
+              <a:ext uri="{FF2B5EF4-FFF2-40B4-BE49-F238E27FC236}">
+                <a16:creationId xmlns:a16="http://schemas.microsoft.com/office/drawing/2014/main" id="{B3BA8065-A436-34A0-9AD4-3E9EBD049870}"/>
+              </a:ext>
+            </a:extLst>
+          </p:cNvPr>
+          <p:cNvSpPr>
+            <a:spLocks noGrp="1"/>
+          </p:cNvSpPr>
+          <p:nvPr>
+            <p:ph type="ftr" sz="quarter" idx="11"/>
+          </p:nvPr>
+        </p:nvSpPr>
+        <p:spPr/>
+        <p:txBody>
+          <a:bodyPr/>
+          <a:lstStyle/>
+          <a:p>
+            <a:r>
+              <a:rPr lang="en-US"/>
+              <a:t>© Steve Beaty and others as cited</a:t>
+            </a:r>
+          </a:p>
+        </p:txBody>
+      </p:sp>
+      <p:sp>
+        <p:nvSpPr>
+          <p:cNvPr id="6" name="Slide Number Placeholder 5">
+            <a:extLst>
+              <a:ext uri="{FF2B5EF4-FFF2-40B4-BE49-F238E27FC236}">
+                <a16:creationId xmlns:a16="http://schemas.microsoft.com/office/drawing/2014/main" id="{E8A0500D-FCE6-ED9C-1AE5-B0B33F9CDE69}"/>
+              </a:ext>
+            </a:extLst>
+          </p:cNvPr>
+          <p:cNvSpPr>
+            <a:spLocks noGrp="1"/>
+          </p:cNvSpPr>
+          <p:nvPr>
+            <p:ph type="sldNum" sz="quarter" idx="12"/>
+          </p:nvPr>
+        </p:nvSpPr>
+        <p:spPr/>
+        <p:txBody>
+          <a:bodyPr/>
+          <a:lstStyle/>
+          <a:p>
+            <a:fld id="{DF323A44-C1E5-0B49-AAF6-7E9549B7BFD2}" type="slidenum">
+              <a:rPr lang="en-US" smtClean="0"/>
+              <a:t>9</a:t>
+            </a:fld>
+            <a:endParaRPr lang="en-US"/>
           </a:p>
         </p:txBody>
       </p:sp>
@@ -10859,7 +13341,7 @@
   <a:extraClrSchemeLst/>
   <a:extLst>
     <a:ext uri="{05A4C25C-085E-4340-85A3-A5531E510DB2}">
-      <thm15:themeFamily xmlns:thm15="http://schemas.microsoft.com/office/thememl/2012/main" name="Cognella" id="{9B7AACB3-BED8-6844-ADDB-C87436244734}" vid="{7749C953-94DA-D341-AC03-734E71A764AB}"/>
+      <thm15:themeFamily xmlns:thm15="http://schemas.microsoft.com/office/thememl/2012/main" name="Presentation1" id="{9DA9736E-330F-4D40-A0AF-1CC780C29072}" vid="{881790AE-4280-6941-9F6C-19A6C408C41E}"/>
     </a:ext>
   </a:extLst>
 </a:theme>

</xml_diff>